<commit_message>
Module 05: four films in Chinese and English, film picker, English slides
Popular-science film (the author's original), concise and advanced films drawn
with the new cine kit, and a walkthrough recorded from the real page. film.json
schema 2, size-constrained LP option, order study traces, regression tests,
build docs, and a home-page module import fix.

Co-Authored-By: Claude Opus 5.5 (1M context) <noreply@anthropic.com>
Claude-Session: https://claude.ai/code/session_01YUzBMRXLXxqyUWCr3UD4wg
</commit_message>
<xml_diff>
--- a/site/slides/m05-label-propagation/m05-label-propagation.pptx
+++ b/site/slides/m05-label-propagation/m05-label-propagation.pptx
@@ -4419,7 +4419,7 @@
         <p:spPr>
           <a:xfrm>
             <a:off x="563880" y="6512052"/>
-            <a:ext cx="1655826" cy="205740"/>
+            <a:ext cx="1647189" cy="205740"/>
           </a:xfrm>
           <a:prstGeom prst="rect">
             <a:avLst/>
@@ -4454,8 +4454,8 @@
         </p:nvSpPr>
         <p:spPr>
           <a:xfrm>
-            <a:off x="11108524" y="6499098"/>
-            <a:ext cx="561505" cy="222885"/>
+            <a:off x="11113770" y="6499098"/>
+            <a:ext cx="556260" cy="222885"/>
           </a:xfrm>
           <a:prstGeom prst="rect">
             <a:avLst/>
@@ -4490,8 +4490,8 @@
         </p:nvSpPr>
         <p:spPr>
           <a:xfrm>
-            <a:off x="9601809" y="377952"/>
-            <a:ext cx="2064410" cy="205740"/>
+            <a:off x="9307830" y="377952"/>
+            <a:ext cx="2358390" cy="205740"/>
           </a:xfrm>
           <a:prstGeom prst="rect">
             <a:avLst/>
@@ -4513,7 +4513,7 @@
                 <a:latin typeface="Noto Sans SC"/>
                 <a:ea typeface="Noto Sans SC"/>
               </a:rPr>
-              <a:t>影片 《圈子从哪里来》 00:00</a:t>
+              <a:t>影片 《精讲：规则与停止》 00:00</a:t>
             </a:r>
           </a:p>
         </p:txBody>
@@ -4562,8 +4562,8 @@
         </p:nvSpPr>
         <p:spPr>
           <a:xfrm>
-            <a:off x="3761473" y="3335782"/>
-            <a:ext cx="4669053" cy="291465"/>
+            <a:off x="3757929" y="3335782"/>
+            <a:ext cx="4676140" cy="291465"/>
           </a:xfrm>
           <a:prstGeom prst="rect">
             <a:avLst/>
@@ -4598,8 +4598,8 @@
         </p:nvSpPr>
         <p:spPr>
           <a:xfrm>
-            <a:off x="4005516" y="4136644"/>
-            <a:ext cx="4180966" cy="240030"/>
+            <a:off x="3991610" y="4136644"/>
+            <a:ext cx="4208780" cy="240030"/>
           </a:xfrm>
           <a:prstGeom prst="rect">
             <a:avLst/>
@@ -4852,7 +4852,7 @@
         <p:spPr>
           <a:xfrm>
             <a:off x="563880" y="6512052"/>
-            <a:ext cx="1655826" cy="205740"/>
+            <a:ext cx="1647189" cy="205740"/>
           </a:xfrm>
           <a:prstGeom prst="rect">
             <a:avLst/>
@@ -4887,8 +4887,8 @@
         </p:nvSpPr>
         <p:spPr>
           <a:xfrm>
-            <a:off x="11011115" y="6499098"/>
-            <a:ext cx="658914" cy="222885"/>
+            <a:off x="11018520" y="6499098"/>
+            <a:ext cx="651510" cy="222885"/>
           </a:xfrm>
           <a:prstGeom prst="rect">
             <a:avLst/>
@@ -4923,8 +4923,8 @@
         </p:nvSpPr>
         <p:spPr>
           <a:xfrm>
-            <a:off x="9601809" y="377952"/>
-            <a:ext cx="2064410" cy="205740"/>
+            <a:off x="9307830" y="377952"/>
+            <a:ext cx="2358390" cy="205740"/>
           </a:xfrm>
           <a:prstGeom prst="rect">
             <a:avLst/>
@@ -4946,7 +4946,7 @@
                 <a:latin typeface="Noto Sans SC"/>
                 <a:ea typeface="Noto Sans SC"/>
               </a:rPr>
-              <a:t>影片 《圈子从哪里来》 02:42</a:t>
+              <a:t>影片 《精讲：规则与停止》 01:31</a:t>
             </a:r>
           </a:p>
         </p:txBody>
@@ -5334,7 +5334,7 @@
         <p:spPr>
           <a:xfrm>
             <a:off x="5898832" y="1768983"/>
-            <a:ext cx="154019" cy="180022"/>
+            <a:ext cx="156210" cy="180022"/>
           </a:xfrm>
           <a:prstGeom prst="rect">
             <a:avLst/>
@@ -5370,7 +5370,7 @@
         <p:spPr>
           <a:xfrm>
             <a:off x="6189027" y="1730120"/>
-            <a:ext cx="821588" cy="231457"/>
+            <a:ext cx="826769" cy="231457"/>
           </a:xfrm>
           <a:prstGeom prst="rect">
             <a:avLst/>
@@ -5405,7 +5405,7 @@
         </p:nvSpPr>
         <p:spPr>
           <a:xfrm>
-            <a:off x="6907745" y="1730120"/>
+            <a:off x="6912927" y="1730120"/>
             <a:ext cx="274320" cy="231457"/>
           </a:xfrm>
           <a:prstGeom prst="rect">
@@ -5441,8 +5441,8 @@
         </p:nvSpPr>
         <p:spPr>
           <a:xfrm>
-            <a:off x="7079195" y="1730120"/>
-            <a:ext cx="230600" cy="231457"/>
+            <a:off x="7084377" y="1730120"/>
+            <a:ext cx="229870" cy="231457"/>
           </a:xfrm>
           <a:prstGeom prst="rect">
             <a:avLst/>
@@ -5478,7 +5478,7 @@
         <p:spPr>
           <a:xfrm>
             <a:off x="5898832" y="2175383"/>
-            <a:ext cx="154019" cy="180022"/>
+            <a:ext cx="156210" cy="180022"/>
           </a:xfrm>
           <a:prstGeom prst="rect">
             <a:avLst/>
@@ -5514,7 +5514,7 @@
         <p:spPr>
           <a:xfrm>
             <a:off x="6189027" y="2136521"/>
-            <a:ext cx="665226" cy="231457"/>
+            <a:ext cx="661670" cy="231457"/>
           </a:xfrm>
           <a:prstGeom prst="rect">
             <a:avLst/>
@@ -5549,7 +5549,7 @@
         </p:nvSpPr>
         <p:spPr>
           <a:xfrm>
-            <a:off x="6751383" y="2136521"/>
+            <a:off x="6747827" y="2136521"/>
             <a:ext cx="617220" cy="231457"/>
           </a:xfrm>
           <a:prstGeom prst="rect">
@@ -5585,8 +5585,8 @@
         </p:nvSpPr>
         <p:spPr>
           <a:xfrm>
-            <a:off x="7265733" y="2136521"/>
-            <a:ext cx="150533" cy="231457"/>
+            <a:off x="7262177" y="2136521"/>
+            <a:ext cx="153670" cy="231457"/>
           </a:xfrm>
           <a:prstGeom prst="rect">
             <a:avLst/>
@@ -5622,7 +5622,7 @@
         <p:spPr>
           <a:xfrm>
             <a:off x="5898832" y="2581783"/>
-            <a:ext cx="154019" cy="180022"/>
+            <a:ext cx="156210" cy="180022"/>
           </a:xfrm>
           <a:prstGeom prst="rect">
             <a:avLst/>
@@ -5658,7 +5658,7 @@
         <p:spPr>
           <a:xfrm>
             <a:off x="6189027" y="2542921"/>
-            <a:ext cx="762095" cy="231457"/>
+            <a:ext cx="750570" cy="231457"/>
           </a:xfrm>
           <a:prstGeom prst="rect">
             <a:avLst/>
@@ -5693,7 +5693,7 @@
         </p:nvSpPr>
         <p:spPr>
           <a:xfrm>
-            <a:off x="6848252" y="2542921"/>
+            <a:off x="6836727" y="2542921"/>
             <a:ext cx="788670" cy="231457"/>
           </a:xfrm>
           <a:prstGeom prst="rect">
@@ -5729,8 +5729,8 @@
         </p:nvSpPr>
         <p:spPr>
           <a:xfrm>
-            <a:off x="7534052" y="2542921"/>
-            <a:ext cx="150533" cy="231457"/>
+            <a:off x="7522527" y="2542921"/>
+            <a:ext cx="153670" cy="231457"/>
           </a:xfrm>
           <a:prstGeom prst="rect">
             <a:avLst/>
@@ -5850,7 +5850,7 @@
         <p:spPr>
           <a:xfrm>
             <a:off x="5898832" y="2988183"/>
-            <a:ext cx="154019" cy="180022"/>
+            <a:ext cx="156210" cy="180022"/>
           </a:xfrm>
           <a:prstGeom prst="rect">
             <a:avLst/>
@@ -5886,7 +5886,7 @@
         <p:spPr>
           <a:xfrm>
             <a:off x="6189027" y="2949321"/>
-            <a:ext cx="727976" cy="231457"/>
+            <a:ext cx="725170" cy="231457"/>
           </a:xfrm>
           <a:prstGeom prst="rect">
             <a:avLst/>
@@ -5921,7 +5921,7 @@
         </p:nvSpPr>
         <p:spPr>
           <a:xfrm>
-            <a:off x="6814134" y="2949321"/>
+            <a:off x="6811327" y="2949321"/>
             <a:ext cx="274320" cy="231457"/>
           </a:xfrm>
           <a:prstGeom prst="rect">
@@ -5957,8 +5957,8 @@
         </p:nvSpPr>
         <p:spPr>
           <a:xfrm>
-            <a:off x="6985584" y="2949321"/>
-            <a:ext cx="141274" cy="231457"/>
+            <a:off x="6982777" y="2949321"/>
+            <a:ext cx="140970" cy="231457"/>
           </a:xfrm>
           <a:prstGeom prst="rect">
             <a:avLst/>
@@ -5993,7 +5993,7 @@
         </p:nvSpPr>
         <p:spPr>
           <a:xfrm>
-            <a:off x="7023989" y="2949321"/>
+            <a:off x="7020877" y="2949321"/>
             <a:ext cx="1645920" cy="231457"/>
           </a:xfrm>
           <a:prstGeom prst="rect">
@@ -6114,7 +6114,7 @@
         <p:spPr>
           <a:xfrm>
             <a:off x="5898832" y="3394583"/>
-            <a:ext cx="154019" cy="180022"/>
+            <a:ext cx="156210" cy="180022"/>
           </a:xfrm>
           <a:prstGeom prst="rect">
             <a:avLst/>
@@ -6150,7 +6150,7 @@
         <p:spPr>
           <a:xfrm>
             <a:off x="6189027" y="3355721"/>
-            <a:ext cx="631964" cy="231457"/>
+            <a:ext cx="629920" cy="231457"/>
           </a:xfrm>
           <a:prstGeom prst="rect">
             <a:avLst/>
@@ -6185,7 +6185,7 @@
         </p:nvSpPr>
         <p:spPr>
           <a:xfrm>
-            <a:off x="6718122" y="3355721"/>
+            <a:off x="6716077" y="3355721"/>
             <a:ext cx="274320" cy="231457"/>
           </a:xfrm>
           <a:prstGeom prst="rect">
@@ -6221,8 +6221,8 @@
         </p:nvSpPr>
         <p:spPr>
           <a:xfrm>
-            <a:off x="6889572" y="3355721"/>
-            <a:ext cx="141274" cy="231457"/>
+            <a:off x="6887527" y="3355721"/>
+            <a:ext cx="140970" cy="231457"/>
           </a:xfrm>
           <a:prstGeom prst="rect">
             <a:avLst/>
@@ -6257,7 +6257,7 @@
         </p:nvSpPr>
         <p:spPr>
           <a:xfrm>
-            <a:off x="6927977" y="3355721"/>
+            <a:off x="6925627" y="3355721"/>
             <a:ext cx="1645920" cy="231457"/>
           </a:xfrm>
           <a:prstGeom prst="rect">
@@ -6294,7 +6294,7 @@
         <p:spPr>
           <a:xfrm>
             <a:off x="5898832" y="3800983"/>
-            <a:ext cx="154019" cy="180022"/>
+            <a:ext cx="156210" cy="180022"/>
           </a:xfrm>
           <a:prstGeom prst="rect">
             <a:avLst/>
@@ -6330,7 +6330,7 @@
         <p:spPr>
           <a:xfrm>
             <a:off x="6189027" y="3762121"/>
-            <a:ext cx="256489" cy="231457"/>
+            <a:ext cx="255270" cy="231457"/>
           </a:xfrm>
           <a:prstGeom prst="rect">
             <a:avLst/>
@@ -6365,7 +6365,7 @@
         </p:nvSpPr>
         <p:spPr>
           <a:xfrm>
-            <a:off x="6342646" y="3762121"/>
+            <a:off x="6341427" y="3762121"/>
             <a:ext cx="2503170" cy="231457"/>
           </a:xfrm>
           <a:prstGeom prst="rect">
@@ -6402,7 +6402,7 @@
         <p:spPr>
           <a:xfrm>
             <a:off x="5898832" y="4207383"/>
-            <a:ext cx="154019" cy="180022"/>
+            <a:ext cx="156210" cy="180022"/>
           </a:xfrm>
           <a:prstGeom prst="rect">
             <a:avLst/>
@@ -6438,7 +6438,7 @@
         <p:spPr>
           <a:xfrm>
             <a:off x="6189027" y="4168521"/>
-            <a:ext cx="179679" cy="231457"/>
+            <a:ext cx="179070" cy="231457"/>
           </a:xfrm>
           <a:prstGeom prst="rect">
             <a:avLst/>
@@ -6473,7 +6473,7 @@
         </p:nvSpPr>
         <p:spPr>
           <a:xfrm>
-            <a:off x="6265837" y="4168521"/>
+            <a:off x="6265227" y="4168521"/>
             <a:ext cx="1645920" cy="231457"/>
           </a:xfrm>
           <a:prstGeom prst="rect">
@@ -6510,7 +6510,7 @@
         <p:spPr>
           <a:xfrm>
             <a:off x="5898832" y="4613783"/>
-            <a:ext cx="154019" cy="180022"/>
+            <a:ext cx="156210" cy="180022"/>
           </a:xfrm>
           <a:prstGeom prst="rect">
             <a:avLst/>
@@ -6546,7 +6546,7 @@
         <p:spPr>
           <a:xfrm>
             <a:off x="6189027" y="4574921"/>
-            <a:ext cx="179679" cy="231457"/>
+            <a:ext cx="179070" cy="231457"/>
           </a:xfrm>
           <a:prstGeom prst="rect">
             <a:avLst/>
@@ -6581,7 +6581,7 @@
         </p:nvSpPr>
         <p:spPr>
           <a:xfrm>
-            <a:off x="6265837" y="4574921"/>
+            <a:off x="6265227" y="4574921"/>
             <a:ext cx="617220" cy="231457"/>
           </a:xfrm>
           <a:prstGeom prst="rect">
@@ -6617,8 +6617,8 @@
         </p:nvSpPr>
         <p:spPr>
           <a:xfrm>
-            <a:off x="6780187" y="4574921"/>
-            <a:ext cx="141274" cy="231457"/>
+            <a:off x="6779577" y="4574921"/>
+            <a:ext cx="140970" cy="231457"/>
           </a:xfrm>
           <a:prstGeom prst="rect">
             <a:avLst/>
@@ -6653,7 +6653,7 @@
         </p:nvSpPr>
         <p:spPr>
           <a:xfrm>
-            <a:off x="6818591" y="4574921"/>
+            <a:off x="6817677" y="4574921"/>
             <a:ext cx="274320" cy="231457"/>
           </a:xfrm>
           <a:prstGeom prst="rect">
@@ -6689,8 +6689,8 @@
         </p:nvSpPr>
         <p:spPr>
           <a:xfrm>
-            <a:off x="6990041" y="4574921"/>
-            <a:ext cx="632307" cy="231457"/>
+            <a:off x="6989127" y="4574921"/>
+            <a:ext cx="636270" cy="231457"/>
           </a:xfrm>
           <a:prstGeom prst="rect">
             <a:avLst/>
@@ -6725,7 +6725,7 @@
         </p:nvSpPr>
         <p:spPr>
           <a:xfrm>
-            <a:off x="7519479" y="4574921"/>
+            <a:off x="7522527" y="4574921"/>
             <a:ext cx="617220" cy="231457"/>
           </a:xfrm>
           <a:prstGeom prst="rect">
@@ -6761,8 +6761,8 @@
         </p:nvSpPr>
         <p:spPr>
           <a:xfrm>
-            <a:off x="8033829" y="4574921"/>
-            <a:ext cx="141274" cy="231457"/>
+            <a:off x="8036877" y="4574921"/>
+            <a:ext cx="140970" cy="231457"/>
           </a:xfrm>
           <a:prstGeom prst="rect">
             <a:avLst/>
@@ -6797,7 +6797,7 @@
         </p:nvSpPr>
         <p:spPr>
           <a:xfrm>
-            <a:off x="8072234" y="4574921"/>
+            <a:off x="8074977" y="4574921"/>
             <a:ext cx="274320" cy="231457"/>
           </a:xfrm>
           <a:prstGeom prst="rect">
@@ -6833,8 +6833,8 @@
         </p:nvSpPr>
         <p:spPr>
           <a:xfrm>
-            <a:off x="8243684" y="4574921"/>
-            <a:ext cx="549154" cy="231457"/>
+            <a:off x="8246427" y="4574921"/>
+            <a:ext cx="553720" cy="231457"/>
           </a:xfrm>
           <a:prstGeom prst="rect">
             <a:avLst/>
@@ -7087,7 +7087,7 @@
         <p:spPr>
           <a:xfrm>
             <a:off x="563880" y="6512052"/>
-            <a:ext cx="1655826" cy="205740"/>
+            <a:ext cx="1647189" cy="205740"/>
           </a:xfrm>
           <a:prstGeom prst="rect">
             <a:avLst/>
@@ -7122,8 +7122,8 @@
         </p:nvSpPr>
         <p:spPr>
           <a:xfrm>
-            <a:off x="11011115" y="6499098"/>
-            <a:ext cx="658914" cy="222885"/>
+            <a:off x="11018520" y="6499098"/>
+            <a:ext cx="651510" cy="222885"/>
           </a:xfrm>
           <a:prstGeom prst="rect">
             <a:avLst/>
@@ -7786,7 +7786,7 @@
         <p:spPr>
           <a:xfrm>
             <a:off x="563880" y="6512052"/>
-            <a:ext cx="1655826" cy="205740"/>
+            <a:ext cx="1647189" cy="205740"/>
           </a:xfrm>
           <a:prstGeom prst="rect">
             <a:avLst/>
@@ -7821,8 +7821,8 @@
         </p:nvSpPr>
         <p:spPr>
           <a:xfrm>
-            <a:off x="11011115" y="6499098"/>
-            <a:ext cx="658914" cy="222885"/>
+            <a:off x="11018520" y="6499098"/>
+            <a:ext cx="651510" cy="222885"/>
           </a:xfrm>
           <a:prstGeom prst="rect">
             <a:avLst/>
@@ -8195,7 +8195,7 @@
         <p:spPr>
           <a:xfrm>
             <a:off x="563880" y="6512052"/>
-            <a:ext cx="1655826" cy="205740"/>
+            <a:ext cx="1647189" cy="205740"/>
           </a:xfrm>
           <a:prstGeom prst="rect">
             <a:avLst/>
@@ -8230,8 +8230,8 @@
         </p:nvSpPr>
         <p:spPr>
           <a:xfrm>
-            <a:off x="11108524" y="6499098"/>
-            <a:ext cx="561505" cy="222885"/>
+            <a:off x="11113770" y="6499098"/>
+            <a:ext cx="556260" cy="222885"/>
           </a:xfrm>
           <a:prstGeom prst="rect">
             <a:avLst/>
@@ -8266,8 +8266,8 @@
         </p:nvSpPr>
         <p:spPr>
           <a:xfrm>
-            <a:off x="9601809" y="377952"/>
-            <a:ext cx="2064410" cy="205740"/>
+            <a:off x="9612630" y="377952"/>
+            <a:ext cx="2053589" cy="205740"/>
           </a:xfrm>
           <a:prstGeom prst="rect">
             <a:avLst/>
@@ -8289,7 +8289,7 @@
                 <a:latin typeface="Noto Sans SC"/>
                 <a:ea typeface="Noto Sans SC"/>
               </a:rPr>
-              <a:t>影片 《圈子从哪里来》 00:14</a:t>
+              <a:t>影片 《圈子从哪里来》 00:34</a:t>
             </a:r>
           </a:p>
         </p:txBody>
@@ -10938,7 +10938,7 @@
             <a:avLst/>
           </a:prstGeom>
           <a:solidFill>
-            <a:srgbClr val="9FD27F"/>
+            <a:srgbClr val="77CDBB"/>
           </a:solidFill>
           <a:ln w="12700">
             <a:solidFill>
@@ -11018,7 +11018,7 @@
             <a:avLst/>
           </a:prstGeom>
           <a:solidFill>
-            <a:srgbClr val="9FD27F"/>
+            <a:srgbClr val="77CDBB"/>
           </a:solidFill>
           <a:ln w="12700">
             <a:solidFill>
@@ -11098,7 +11098,7 @@
             <a:avLst/>
           </a:prstGeom>
           <a:solidFill>
-            <a:srgbClr val="9FD27F"/>
+            <a:srgbClr val="77CDBB"/>
           </a:solidFill>
           <a:ln w="12700">
             <a:solidFill>
@@ -11178,7 +11178,7 @@
             <a:avLst/>
           </a:prstGeom>
           <a:solidFill>
-            <a:srgbClr val="9FD27F"/>
+            <a:srgbClr val="77CDBB"/>
           </a:solidFill>
           <a:ln w="12700">
             <a:solidFill>
@@ -11258,7 +11258,7 @@
             <a:avLst/>
           </a:prstGeom>
           <a:solidFill>
-            <a:srgbClr val="9FD27F"/>
+            <a:srgbClr val="77CDBB"/>
           </a:solidFill>
           <a:ln w="12700">
             <a:solidFill>
@@ -11338,7 +11338,7 @@
             <a:avLst/>
           </a:prstGeom>
           <a:solidFill>
-            <a:srgbClr val="9FD27F"/>
+            <a:srgbClr val="77CDBB"/>
           </a:solidFill>
           <a:ln w="12700">
             <a:solidFill>
@@ -11418,7 +11418,7 @@
             <a:avLst/>
           </a:prstGeom>
           <a:solidFill>
-            <a:srgbClr val="9FD27F"/>
+            <a:srgbClr val="77CDBB"/>
           </a:solidFill>
           <a:ln w="12700">
             <a:solidFill>
@@ -11498,7 +11498,7 @@
             <a:avLst/>
           </a:prstGeom>
           <a:solidFill>
-            <a:srgbClr val="9FD27F"/>
+            <a:srgbClr val="77CDBB"/>
           </a:solidFill>
           <a:ln w="12700">
             <a:solidFill>
@@ -11578,7 +11578,7 @@
             <a:avLst/>
           </a:prstGeom>
           <a:solidFill>
-            <a:srgbClr val="D8BB78"/>
+            <a:srgbClr val="8FB1E6"/>
           </a:solidFill>
           <a:ln w="12700">
             <a:solidFill>
@@ -11658,7 +11658,7 @@
             <a:avLst/>
           </a:prstGeom>
           <a:solidFill>
-            <a:srgbClr val="D8BB78"/>
+            <a:srgbClr val="8FB1E6"/>
           </a:solidFill>
           <a:ln w="12700">
             <a:solidFill>
@@ -11738,7 +11738,7 @@
             <a:avLst/>
           </a:prstGeom>
           <a:solidFill>
-            <a:srgbClr val="D8BB78"/>
+            <a:srgbClr val="8FB1E6"/>
           </a:solidFill>
           <a:ln w="12700">
             <a:solidFill>
@@ -11818,7 +11818,7 @@
             <a:avLst/>
           </a:prstGeom>
           <a:solidFill>
-            <a:srgbClr val="D8BB78"/>
+            <a:srgbClr val="8FB1E6"/>
           </a:solidFill>
           <a:ln w="12700">
             <a:solidFill>
@@ -11898,7 +11898,7 @@
             <a:avLst/>
           </a:prstGeom>
           <a:solidFill>
-            <a:srgbClr val="D8BB78"/>
+            <a:srgbClr val="8FB1E6"/>
           </a:solidFill>
           <a:ln w="12700">
             <a:solidFill>
@@ -11978,7 +11978,7 @@
             <a:avLst/>
           </a:prstGeom>
           <a:solidFill>
-            <a:srgbClr val="D8BB78"/>
+            <a:srgbClr val="8FB1E6"/>
           </a:solidFill>
           <a:ln w="12700">
             <a:solidFill>
@@ -12058,7 +12058,7 @@
             <a:avLst/>
           </a:prstGeom>
           <a:solidFill>
-            <a:srgbClr val="D8BB78"/>
+            <a:srgbClr val="8FB1E6"/>
           </a:solidFill>
           <a:ln w="12700">
             <a:solidFill>
@@ -12138,7 +12138,7 @@
             <a:avLst/>
           </a:prstGeom>
           <a:solidFill>
-            <a:srgbClr val="D8BB78"/>
+            <a:srgbClr val="8FB1E6"/>
           </a:solidFill>
           <a:ln w="12700">
             <a:solidFill>
@@ -12218,7 +12218,7 @@
             <a:avLst/>
           </a:prstGeom>
           <a:solidFill>
-            <a:srgbClr val="D8BB78"/>
+            <a:srgbClr val="8FB1E6"/>
           </a:solidFill>
           <a:ln w="12700">
             <a:solidFill>
@@ -12298,7 +12298,7 @@
             <a:avLst/>
           </a:prstGeom>
           <a:solidFill>
-            <a:srgbClr val="D8BB78"/>
+            <a:srgbClr val="8FB1E6"/>
           </a:solidFill>
           <a:ln w="12700">
             <a:solidFill>
@@ -12378,7 +12378,7 @@
             <a:avLst/>
           </a:prstGeom>
           <a:solidFill>
-            <a:srgbClr val="E39FB8"/>
+            <a:srgbClr val="D8BB78"/>
           </a:solidFill>
           <a:ln w="12700">
             <a:solidFill>
@@ -12458,7 +12458,7 @@
             <a:avLst/>
           </a:prstGeom>
           <a:solidFill>
-            <a:srgbClr val="E39FB8"/>
+            <a:srgbClr val="D8BB78"/>
           </a:solidFill>
           <a:ln w="12700">
             <a:solidFill>
@@ -12538,7 +12538,7 @@
             <a:avLst/>
           </a:prstGeom>
           <a:solidFill>
-            <a:srgbClr val="E39FB8"/>
+            <a:srgbClr val="D8BB78"/>
           </a:solidFill>
           <a:ln w="12700">
             <a:solidFill>
@@ -12618,7 +12618,7 @@
             <a:avLst/>
           </a:prstGeom>
           <a:solidFill>
-            <a:srgbClr val="E39FB8"/>
+            <a:srgbClr val="D8BB78"/>
           </a:solidFill>
           <a:ln w="12700">
             <a:solidFill>
@@ -12698,7 +12698,7 @@
             <a:avLst/>
           </a:prstGeom>
           <a:solidFill>
-            <a:srgbClr val="E39FB8"/>
+            <a:srgbClr val="D8BB78"/>
           </a:solidFill>
           <a:ln w="12700">
             <a:solidFill>
@@ -12778,7 +12778,7 @@
             <a:avLst/>
           </a:prstGeom>
           <a:solidFill>
-            <a:srgbClr val="E39FB8"/>
+            <a:srgbClr val="D8BB78"/>
           </a:solidFill>
           <a:ln w="12700">
             <a:solidFill>
@@ -12858,7 +12858,7 @@
             <a:avLst/>
           </a:prstGeom>
           <a:solidFill>
-            <a:srgbClr val="E39FB8"/>
+            <a:srgbClr val="D8BB78"/>
           </a:solidFill>
           <a:ln w="12700">
             <a:solidFill>
@@ -12938,7 +12938,7 @@
             <a:avLst/>
           </a:prstGeom>
           <a:solidFill>
-            <a:srgbClr val="E39FB8"/>
+            <a:srgbClr val="D8BB78"/>
           </a:solidFill>
           <a:ln w="12700">
             <a:solidFill>
@@ -13018,7 +13018,7 @@
             <a:avLst/>
           </a:prstGeom>
           <a:solidFill>
-            <a:srgbClr val="E39FB8"/>
+            <a:srgbClr val="D8BB78"/>
           </a:solidFill>
           <a:ln w="12700">
             <a:solidFill>
@@ -13098,7 +13098,7 @@
             <a:avLst/>
           </a:prstGeom>
           <a:solidFill>
-            <a:srgbClr val="E39FB8"/>
+            <a:srgbClr val="D8BB78"/>
           </a:solidFill>
           <a:ln w="12700">
             <a:solidFill>
@@ -13171,8 +13171,8 @@
         </p:nvSpPr>
         <p:spPr>
           <a:xfrm>
-            <a:off x="7662913" y="5689600"/>
-            <a:ext cx="1946173" cy="292100"/>
+            <a:off x="7664450" y="5689600"/>
+            <a:ext cx="1943100" cy="292100"/>
           </a:xfrm>
           <a:prstGeom prst="roundRect">
             <a:avLst>
@@ -13217,8 +13217,8 @@
         </p:nvSpPr>
         <p:spPr>
           <a:xfrm>
-            <a:off x="7708633" y="5749798"/>
-            <a:ext cx="1854733" cy="222885"/>
+            <a:off x="7710170" y="5749798"/>
+            <a:ext cx="1851660" cy="222885"/>
           </a:xfrm>
           <a:prstGeom prst="rect">
             <a:avLst/>
@@ -13471,7 +13471,7 @@
         <p:spPr>
           <a:xfrm>
             <a:off x="563880" y="6512052"/>
-            <a:ext cx="1655826" cy="205740"/>
+            <a:ext cx="1647189" cy="205740"/>
           </a:xfrm>
           <a:prstGeom prst="rect">
             <a:avLst/>
@@ -13506,8 +13506,8 @@
         </p:nvSpPr>
         <p:spPr>
           <a:xfrm>
-            <a:off x="11108524" y="6499098"/>
-            <a:ext cx="561505" cy="222885"/>
+            <a:off x="11113770" y="6499098"/>
+            <a:ext cx="556260" cy="222885"/>
           </a:xfrm>
           <a:prstGeom prst="rect">
             <a:avLst/>
@@ -13542,8 +13542,8 @@
         </p:nvSpPr>
         <p:spPr>
           <a:xfrm>
-            <a:off x="9601809" y="377952"/>
-            <a:ext cx="2064410" cy="205740"/>
+            <a:off x="9612630" y="377952"/>
+            <a:ext cx="2053589" cy="205740"/>
           </a:xfrm>
           <a:prstGeom prst="rect">
             <a:avLst/>
@@ -13565,7 +13565,7 @@
                 <a:latin typeface="Noto Sans SC"/>
                 <a:ea typeface="Noto Sans SC"/>
               </a:rPr>
-              <a:t>影片 《圈子从哪里来》 00:29</a:t>
+              <a:t>影片 《圈子从哪里来》 00:51</a:t>
             </a:r>
           </a:p>
         </p:txBody>
@@ -17064,8 +17064,8 @@
         </p:nvSpPr>
         <p:spPr>
           <a:xfrm>
-            <a:off x="7944821" y="5689600"/>
-            <a:ext cx="1382356" cy="292100"/>
+            <a:off x="7943850" y="5689600"/>
+            <a:ext cx="1384300" cy="292100"/>
           </a:xfrm>
           <a:prstGeom prst="roundRect">
             <a:avLst>
@@ -17110,8 +17110,8 @@
         </p:nvSpPr>
         <p:spPr>
           <a:xfrm>
-            <a:off x="7990541" y="5749798"/>
-            <a:ext cx="1290916" cy="222885"/>
+            <a:off x="7989570" y="5749798"/>
+            <a:ext cx="1292860" cy="222885"/>
           </a:xfrm>
           <a:prstGeom prst="rect">
             <a:avLst/>
@@ -17364,7 +17364,7 @@
         <p:spPr>
           <a:xfrm>
             <a:off x="563880" y="6512052"/>
-            <a:ext cx="1655826" cy="205740"/>
+            <a:ext cx="1647189" cy="205740"/>
           </a:xfrm>
           <a:prstGeom prst="rect">
             <a:avLst/>
@@ -17399,8 +17399,8 @@
         </p:nvSpPr>
         <p:spPr>
           <a:xfrm>
-            <a:off x="11108524" y="6499098"/>
-            <a:ext cx="561505" cy="222885"/>
+            <a:off x="11113770" y="6499098"/>
+            <a:ext cx="556260" cy="222885"/>
           </a:xfrm>
           <a:prstGeom prst="rect">
             <a:avLst/>
@@ -17435,8 +17435,8 @@
         </p:nvSpPr>
         <p:spPr>
           <a:xfrm>
-            <a:off x="9601809" y="377952"/>
-            <a:ext cx="2064410" cy="205740"/>
+            <a:off x="9307830" y="377952"/>
+            <a:ext cx="2358390" cy="205740"/>
           </a:xfrm>
           <a:prstGeom prst="rect">
             <a:avLst/>
@@ -17458,7 +17458,7 @@
                 <a:latin typeface="Noto Sans SC"/>
                 <a:ea typeface="Noto Sans SC"/>
               </a:rPr>
-              <a:t>影片 《圈子从哪里来》 01:02</a:t>
+              <a:t>影片 《精讲：规则与停止》 00:28</a:t>
             </a:r>
           </a:p>
         </p:txBody>
@@ -17879,8 +17879,8 @@
         </p:nvSpPr>
         <p:spPr>
           <a:xfrm>
-            <a:off x="7720817" y="1365474"/>
-            <a:ext cx="241808" cy="274320"/>
+            <a:off x="7720436" y="1365474"/>
+            <a:ext cx="242570" cy="274320"/>
           </a:xfrm>
           <a:prstGeom prst="rect">
             <a:avLst/>
@@ -17995,8 +17995,8 @@
         </p:nvSpPr>
         <p:spPr>
           <a:xfrm>
-            <a:off x="7432413" y="2332763"/>
-            <a:ext cx="241808" cy="274320"/>
+            <a:off x="7432032" y="2332763"/>
+            <a:ext cx="242570" cy="274320"/>
           </a:xfrm>
           <a:prstGeom prst="rect">
             <a:avLst/>
@@ -18111,8 +18111,8 @@
         </p:nvSpPr>
         <p:spPr>
           <a:xfrm>
-            <a:off x="8533733" y="2417380"/>
-            <a:ext cx="241808" cy="274320"/>
+            <a:off x="8533352" y="2417380"/>
+            <a:ext cx="242570" cy="274320"/>
           </a:xfrm>
           <a:prstGeom prst="rect">
             <a:avLst/>
@@ -18227,8 +18227,8 @@
         </p:nvSpPr>
         <p:spPr>
           <a:xfrm>
-            <a:off x="9148360" y="3642165"/>
-            <a:ext cx="241808" cy="274320"/>
+            <a:off x="9147979" y="3642165"/>
+            <a:ext cx="242570" cy="274320"/>
           </a:xfrm>
           <a:prstGeom prst="rect">
             <a:avLst/>
@@ -18343,8 +18343,8 @@
         </p:nvSpPr>
         <p:spPr>
           <a:xfrm>
-            <a:off x="8004937" y="4122176"/>
-            <a:ext cx="241808" cy="274320"/>
+            <a:off x="8004556" y="4122176"/>
+            <a:ext cx="242570" cy="274320"/>
           </a:xfrm>
           <a:prstGeom prst="rect">
             <a:avLst/>
@@ -18459,8 +18459,8 @@
         </p:nvSpPr>
         <p:spPr>
           <a:xfrm>
-            <a:off x="8999286" y="4763996"/>
-            <a:ext cx="241808" cy="274320"/>
+            <a:off x="8998905" y="4763996"/>
+            <a:ext cx="242570" cy="274320"/>
           </a:xfrm>
           <a:prstGeom prst="rect">
             <a:avLst/>
@@ -18539,8 +18539,8 @@
         </p:nvSpPr>
         <p:spPr>
           <a:xfrm>
-            <a:off x="6635075" y="1656076"/>
-            <a:ext cx="269659" cy="291465"/>
+            <a:off x="6635284" y="1656076"/>
+            <a:ext cx="269240" cy="291465"/>
           </a:xfrm>
           <a:prstGeom prst="rect">
             <a:avLst/>
@@ -18575,8 +18575,8 @@
         </p:nvSpPr>
         <p:spPr>
           <a:xfrm>
-            <a:off x="6473766" y="2141470"/>
-            <a:ext cx="592277" cy="266700"/>
+            <a:off x="6474629" y="2141470"/>
+            <a:ext cx="590550" cy="266700"/>
           </a:xfrm>
           <a:prstGeom prst="roundRect">
             <a:avLst>
@@ -18621,8 +18621,8 @@
         </p:nvSpPr>
         <p:spPr>
           <a:xfrm>
-            <a:off x="6527106" y="2202176"/>
-            <a:ext cx="485597" cy="188595"/>
+            <a:off x="6527969" y="2202176"/>
+            <a:ext cx="483870" cy="188595"/>
           </a:xfrm>
           <a:prstGeom prst="rect">
             <a:avLst/>
@@ -18701,8 +18701,8 @@
         </p:nvSpPr>
         <p:spPr>
           <a:xfrm>
-            <a:off x="8795987" y="1508506"/>
-            <a:ext cx="276567" cy="291465"/>
+            <a:off x="8796476" y="1508506"/>
+            <a:ext cx="275590" cy="291465"/>
           </a:xfrm>
           <a:prstGeom prst="rect">
             <a:avLst/>
@@ -18737,8 +18737,8 @@
         </p:nvSpPr>
         <p:spPr>
           <a:xfrm>
-            <a:off x="8635897" y="1993900"/>
-            <a:ext cx="596747" cy="266700"/>
+            <a:off x="8635821" y="1993900"/>
+            <a:ext cx="596900" cy="266700"/>
           </a:xfrm>
           <a:prstGeom prst="roundRect">
             <a:avLst>
@@ -18783,8 +18783,8 @@
         </p:nvSpPr>
         <p:spPr>
           <a:xfrm>
-            <a:off x="8689237" y="2054606"/>
-            <a:ext cx="490067" cy="188595"/>
+            <a:off x="8689161" y="2054606"/>
+            <a:ext cx="490220" cy="188595"/>
           </a:xfrm>
           <a:prstGeom prst="rect">
             <a:avLst/>
@@ -18863,8 +18863,8 @@
         </p:nvSpPr>
         <p:spPr>
           <a:xfrm>
-            <a:off x="7962453" y="3328541"/>
-            <a:ext cx="271170" cy="291465"/>
+            <a:off x="7963418" y="3328541"/>
+            <a:ext cx="269240" cy="291465"/>
           </a:xfrm>
           <a:prstGeom prst="rect">
             <a:avLst/>
@@ -18899,8 +18899,8 @@
         </p:nvSpPr>
         <p:spPr>
           <a:xfrm>
-            <a:off x="7801411" y="3813935"/>
-            <a:ext cx="593255" cy="266700"/>
+            <a:off x="7802763" y="3813935"/>
+            <a:ext cx="590550" cy="266700"/>
           </a:xfrm>
           <a:prstGeom prst="roundRect">
             <a:avLst>
@@ -18945,8 +18945,8 @@
         </p:nvSpPr>
         <p:spPr>
           <a:xfrm>
-            <a:off x="7854751" y="3874641"/>
-            <a:ext cx="486575" cy="188595"/>
+            <a:off x="7856103" y="3874641"/>
+            <a:ext cx="483870" cy="188595"/>
           </a:xfrm>
           <a:prstGeom prst="rect">
             <a:avLst/>
@@ -19025,8 +19025,8 @@
         </p:nvSpPr>
         <p:spPr>
           <a:xfrm>
-            <a:off x="10169748" y="4361534"/>
-            <a:ext cx="283692" cy="291465"/>
+            <a:off x="10170625" y="4361534"/>
+            <a:ext cx="281939" cy="291465"/>
           </a:xfrm>
           <a:prstGeom prst="rect">
             <a:avLst/>
@@ -19061,8 +19061,8 @@
         </p:nvSpPr>
         <p:spPr>
           <a:xfrm>
-            <a:off x="10010916" y="4846928"/>
-            <a:ext cx="601357" cy="266700"/>
+            <a:off x="10009970" y="4846928"/>
+            <a:ext cx="603250" cy="266700"/>
           </a:xfrm>
           <a:prstGeom prst="roundRect">
             <a:avLst>
@@ -19107,8 +19107,8 @@
         </p:nvSpPr>
         <p:spPr>
           <a:xfrm>
-            <a:off x="10064256" y="4907634"/>
-            <a:ext cx="494677" cy="188595"/>
+            <a:off x="10063310" y="4907634"/>
+            <a:ext cx="496570" cy="188595"/>
           </a:xfrm>
           <a:prstGeom prst="rect">
             <a:avLst/>
@@ -19187,8 +19187,8 @@
         </p:nvSpPr>
         <p:spPr>
           <a:xfrm>
-            <a:off x="7720928" y="5001006"/>
-            <a:ext cx="262318" cy="291465"/>
+            <a:off x="7720643" y="5001006"/>
+            <a:ext cx="262890" cy="291465"/>
           </a:xfrm>
           <a:prstGeom prst="rect">
             <a:avLst/>
@@ -19223,8 +19223,8 @@
         </p:nvSpPr>
         <p:spPr>
           <a:xfrm>
-            <a:off x="7558324" y="5486400"/>
-            <a:ext cx="587527" cy="266700"/>
+            <a:off x="7556813" y="5486400"/>
+            <a:ext cx="590550" cy="266700"/>
           </a:xfrm>
           <a:prstGeom prst="roundRect">
             <a:avLst>
@@ -19269,8 +19269,8 @@
         </p:nvSpPr>
         <p:spPr>
           <a:xfrm>
-            <a:off x="7611664" y="5547106"/>
-            <a:ext cx="480847" cy="188595"/>
+            <a:off x="7610153" y="5547106"/>
+            <a:ext cx="483870" cy="188595"/>
           </a:xfrm>
           <a:prstGeom prst="rect">
             <a:avLst/>
@@ -19523,7 +19523,7 @@
         <p:spPr>
           <a:xfrm>
             <a:off x="563880" y="6512052"/>
-            <a:ext cx="1655826" cy="205740"/>
+            <a:ext cx="1647189" cy="205740"/>
           </a:xfrm>
           <a:prstGeom prst="rect">
             <a:avLst/>
@@ -19558,8 +19558,8 @@
         </p:nvSpPr>
         <p:spPr>
           <a:xfrm>
-            <a:off x="11108524" y="6499098"/>
-            <a:ext cx="561505" cy="222885"/>
+            <a:off x="11113770" y="6499098"/>
+            <a:ext cx="556260" cy="222885"/>
           </a:xfrm>
           <a:prstGeom prst="rect">
             <a:avLst/>
@@ -19594,8 +19594,8 @@
         </p:nvSpPr>
         <p:spPr>
           <a:xfrm>
-            <a:off x="9601809" y="377952"/>
-            <a:ext cx="2064410" cy="205740"/>
+            <a:off x="9307830" y="377952"/>
+            <a:ext cx="2358390" cy="205740"/>
           </a:xfrm>
           <a:prstGeom prst="rect">
             <a:avLst/>
@@ -19617,7 +19617,7 @@
                 <a:latin typeface="Noto Sans SC"/>
                 <a:ea typeface="Noto Sans SC"/>
               </a:rPr>
-              <a:t>影片 《圈子从哪里来》 01:18</a:t>
+              <a:t>影片 《精讲：规则与停止》 00:41</a:t>
             </a:r>
           </a:p>
         </p:txBody>
@@ -19958,13 +19958,13 @@
         </p:nvCxnSpPr>
         <p:spPr>
           <a:xfrm flipV="1">
-            <a:off x="6351833" y="2336800"/>
-            <a:ext cx="1515056" cy="103299"/>
+            <a:off x="5571481" y="2405380"/>
+            <a:ext cx="1341907" cy="91493"/>
           </a:xfrm>
           <a:prstGeom prst="line">
             <a:avLst/>
           </a:prstGeom>
-          <a:ln w="22225">
+          <a:ln w="19685">
             <a:solidFill>
               <a:srgbClr val="9FC9BF"/>
             </a:solidFill>
@@ -19993,8 +19993,8 @@
         </p:nvSpPr>
         <p:spPr>
           <a:xfrm>
-            <a:off x="6999692" y="2131242"/>
-            <a:ext cx="204825" cy="204825"/>
+            <a:off x="6145298" y="2223314"/>
+            <a:ext cx="181416" cy="181416"/>
           </a:xfrm>
           <a:prstGeom prst="ellipse">
             <a:avLst/>
@@ -20037,8 +20037,8 @@
         </p:nvSpPr>
         <p:spPr>
           <a:xfrm>
-            <a:off x="7017472" y="2136931"/>
-            <a:ext cx="169265" cy="192024"/>
+            <a:off x="6160810" y="2228354"/>
+            <a:ext cx="150393" cy="170078"/>
           </a:xfrm>
           <a:prstGeom prst="rect">
             <a:avLst/>
@@ -20053,7 +20053,7 @@
           <a:p>
             <a:pPr algn="ctr"/>
             <a:r>
-              <a:rPr sz="1120" b="1">
+              <a:rPr sz="992" b="1">
                 <a:solidFill>
                   <a:srgbClr val="D9E4E1"/>
                 </a:solidFill>
@@ -20073,13 +20073,13 @@
         </p:nvCxnSpPr>
         <p:spPr>
           <a:xfrm>
-            <a:off x="6351833" y="2440099"/>
-            <a:ext cx="929694" cy="1170725"/>
+            <a:off x="5571481" y="2496873"/>
+            <a:ext cx="823443" cy="1036928"/>
           </a:xfrm>
           <a:prstGeom prst="line">
             <a:avLst/>
           </a:prstGeom>
-          <a:ln w="17780">
+          <a:ln w="15748">
             <a:solidFill>
               <a:srgbClr val="DB7B72"/>
             </a:solidFill>
@@ -20109,8 +20109,8 @@
         </p:nvSpPr>
         <p:spPr>
           <a:xfrm>
-            <a:off x="6797809" y="2808345"/>
-            <a:ext cx="204825" cy="204825"/>
+            <a:off x="5966488" y="2823034"/>
+            <a:ext cx="181416" cy="181416"/>
           </a:xfrm>
           <a:prstGeom prst="ellipse">
             <a:avLst/>
@@ -20153,8 +20153,8 @@
         </p:nvSpPr>
         <p:spPr>
           <a:xfrm>
-            <a:off x="6815589" y="2814034"/>
-            <a:ext cx="169265" cy="192024"/>
+            <a:off x="5982000" y="2828073"/>
+            <a:ext cx="150393" cy="170078"/>
           </a:xfrm>
           <a:prstGeom prst="rect">
             <a:avLst/>
@@ -20169,7 +20169,7 @@
           <a:p>
             <a:pPr algn="ctr"/>
             <a:r>
-              <a:rPr sz="1120" b="1">
+              <a:rPr sz="992" b="1">
                 <a:solidFill>
                   <a:srgbClr val="D9E4E1"/>
                 </a:solidFill>
@@ -20189,13 +20189,13 @@
         </p:nvCxnSpPr>
         <p:spPr>
           <a:xfrm flipH="1">
-            <a:off x="7281527" y="2336800"/>
-            <a:ext cx="585362" cy="1274024"/>
+            <a:off x="6394924" y="2405380"/>
+            <a:ext cx="518464" cy="1128421"/>
           </a:xfrm>
           <a:prstGeom prst="line">
             <a:avLst/>
           </a:prstGeom>
-          <a:ln w="17780">
+          <a:ln w="15748">
             <a:solidFill>
               <a:srgbClr val="DB7B72"/>
             </a:solidFill>
@@ -20225,8 +20225,8 @@
         </p:nvSpPr>
         <p:spPr>
           <a:xfrm>
-            <a:off x="7568733" y="2867576"/>
-            <a:ext cx="204825" cy="204825"/>
+            <a:off x="6649306" y="2875496"/>
+            <a:ext cx="181416" cy="181416"/>
           </a:xfrm>
           <a:prstGeom prst="ellipse">
             <a:avLst/>
@@ -20269,8 +20269,8 @@
         </p:nvSpPr>
         <p:spPr>
           <a:xfrm>
-            <a:off x="7586513" y="2873266"/>
-            <a:ext cx="169265" cy="192024"/>
+            <a:off x="6664818" y="2880535"/>
+            <a:ext cx="150393" cy="170078"/>
           </a:xfrm>
           <a:prstGeom prst="rect">
             <a:avLst/>
@@ -20285,7 +20285,7 @@
           <a:p>
             <a:pPr algn="ctr"/>
             <a:r>
-              <a:rPr sz="1120" b="1">
+              <a:rPr sz="992" b="1">
                 <a:solidFill>
                   <a:srgbClr val="D9E4E1"/>
                 </a:solidFill>
@@ -20305,13 +20305,13 @@
         </p:nvCxnSpPr>
         <p:spPr>
           <a:xfrm>
-            <a:off x="7281527" y="3610824"/>
-            <a:ext cx="1549489" cy="723095"/>
+            <a:off x="6394924" y="3533801"/>
+            <a:ext cx="1372404" cy="640456"/>
           </a:xfrm>
           <a:prstGeom prst="line">
             <a:avLst/>
           </a:prstGeom>
-          <a:ln w="17780">
+          <a:ln w="15748">
             <a:solidFill>
               <a:srgbClr val="DB7B72"/>
             </a:solidFill>
@@ -20341,8 +20341,8 @@
         </p:nvSpPr>
         <p:spPr>
           <a:xfrm>
-            <a:off x="7998972" y="3724926"/>
-            <a:ext cx="204825" cy="204825"/>
+            <a:off x="7030375" y="3634863"/>
+            <a:ext cx="181416" cy="181416"/>
           </a:xfrm>
           <a:prstGeom prst="ellipse">
             <a:avLst/>
@@ -20385,8 +20385,8 @@
         </p:nvSpPr>
         <p:spPr>
           <a:xfrm>
-            <a:off x="8016752" y="3730615"/>
-            <a:ext cx="169265" cy="192024"/>
+            <a:off x="7045887" y="3639902"/>
+            <a:ext cx="150393" cy="170078"/>
           </a:xfrm>
           <a:prstGeom prst="rect">
             <a:avLst/>
@@ -20401,7 +20401,7 @@
           <a:p>
             <a:pPr algn="ctr"/>
             <a:r>
-              <a:rPr sz="1120" b="1">
+              <a:rPr sz="992" b="1">
                 <a:solidFill>
                   <a:srgbClr val="D9E4E1"/>
                 </a:solidFill>
@@ -20421,13 +20421,13 @@
         </p:nvCxnSpPr>
         <p:spPr>
           <a:xfrm flipH="1">
-            <a:off x="7109361" y="3610824"/>
-            <a:ext cx="172166" cy="1170726"/>
+            <a:off x="6242434" y="3533801"/>
+            <a:ext cx="152490" cy="1036929"/>
           </a:xfrm>
           <a:prstGeom prst="line">
             <a:avLst/>
           </a:prstGeom>
-          <a:ln w="17780">
+          <a:ln w="15748">
             <a:solidFill>
               <a:srgbClr val="DB7B72"/>
             </a:solidFill>
@@ -20457,8 +20457,8 @@
         </p:nvSpPr>
         <p:spPr>
           <a:xfrm>
-            <a:off x="7198576" y="4060934"/>
-            <a:ext cx="204825" cy="204825"/>
+            <a:off x="6321453" y="3932470"/>
+            <a:ext cx="181416" cy="181416"/>
           </a:xfrm>
           <a:prstGeom prst="ellipse">
             <a:avLst/>
@@ -20501,8 +20501,8 @@
         </p:nvSpPr>
         <p:spPr>
           <a:xfrm>
-            <a:off x="7216356" y="4066623"/>
-            <a:ext cx="169265" cy="192024"/>
+            <a:off x="6336965" y="3937509"/>
+            <a:ext cx="150393" cy="170078"/>
           </a:xfrm>
           <a:prstGeom prst="rect">
             <a:avLst/>
@@ -20517,7 +20517,7 @@
           <a:p>
             <a:pPr algn="ctr"/>
             <a:r>
-              <a:rPr sz="1120" b="1">
+              <a:rPr sz="992" b="1">
                 <a:solidFill>
                   <a:srgbClr val="D9E4E1"/>
                 </a:solidFill>
@@ -20537,13 +20537,13 @@
         </p:nvCxnSpPr>
         <p:spPr>
           <a:xfrm flipH="1">
-            <a:off x="7109361" y="4333919"/>
-            <a:ext cx="1721655" cy="447631"/>
+            <a:off x="6242434" y="4174257"/>
+            <a:ext cx="1524894" cy="396473"/>
           </a:xfrm>
           <a:prstGeom prst="line">
             <a:avLst/>
           </a:prstGeom>
-          <a:ln w="17780">
+          <a:ln w="15748">
             <a:solidFill>
               <a:srgbClr val="DB7B72"/>
             </a:solidFill>
@@ -20573,8 +20573,8 @@
         </p:nvSpPr>
         <p:spPr>
           <a:xfrm>
-            <a:off x="7894620" y="4510207"/>
-            <a:ext cx="204825" cy="204825"/>
+            <a:off x="6937949" y="4330398"/>
+            <a:ext cx="181416" cy="181416"/>
           </a:xfrm>
           <a:prstGeom prst="ellipse">
             <a:avLst/>
@@ -20617,8 +20617,8 @@
         </p:nvSpPr>
         <p:spPr>
           <a:xfrm>
-            <a:off x="7912400" y="4515897"/>
-            <a:ext cx="169265" cy="192024"/>
+            <a:off x="6953461" y="4335437"/>
+            <a:ext cx="150393" cy="170078"/>
           </a:xfrm>
           <a:prstGeom prst="rect">
             <a:avLst/>
@@ -20633,7 +20633,7 @@
           <a:p>
             <a:pPr algn="ctr"/>
             <a:r>
-              <a:rPr sz="1120" b="1">
+              <a:rPr sz="992" b="1">
                 <a:solidFill>
                   <a:srgbClr val="D9E4E1"/>
                 </a:solidFill>
@@ -20653,8 +20653,8 @@
         </p:nvSpPr>
         <p:spPr>
           <a:xfrm>
-            <a:off x="6174033" y="2262299"/>
-            <a:ext cx="355600" cy="355600"/>
+            <a:off x="5414001" y="2339393"/>
+            <a:ext cx="314960" cy="314960"/>
           </a:xfrm>
           <a:prstGeom prst="ellipse">
             <a:avLst/>
@@ -20662,7 +20662,7 @@
           <a:solidFill>
             <a:srgbClr val="8FB1E6"/>
           </a:solidFill>
-          <a:ln w="13334">
+          <a:ln w="11811">
             <a:solidFill>
               <a:srgbClr val="061418"/>
             </a:solidFill>
@@ -20697,8 +20697,8 @@
         </p:nvSpPr>
         <p:spPr>
           <a:xfrm>
-            <a:off x="6257452" y="2340353"/>
-            <a:ext cx="188761" cy="204025"/>
+            <a:off x="5488016" y="2408527"/>
+            <a:ext cx="166928" cy="180708"/>
           </a:xfrm>
           <a:prstGeom prst="rect">
             <a:avLst/>
@@ -20713,7 +20713,7 @@
           <a:p>
             <a:pPr algn="ctr"/>
             <a:r>
-              <a:rPr sz="1189" b="1">
+              <a:rPr sz="1054" b="1">
                 <a:solidFill>
                   <a:srgbClr val="0B1B1F"/>
                 </a:solidFill>
@@ -20733,8 +20733,8 @@
         </p:nvSpPr>
         <p:spPr>
           <a:xfrm>
-            <a:off x="6142971" y="2680129"/>
-            <a:ext cx="417723" cy="186690"/>
+            <a:off x="5386442" y="2709471"/>
+            <a:ext cx="370078" cy="165354"/>
           </a:xfrm>
           <a:prstGeom prst="roundRect">
             <a:avLst>
@@ -20744,7 +20744,7 @@
           <a:solidFill>
             <a:srgbClr val="0A2126"/>
           </a:solidFill>
-          <a:ln w="8890">
+          <a:ln w="7874">
             <a:solidFill>
               <a:srgbClr val="8FB1E6"/>
             </a:solidFill>
@@ -20779,8 +20779,8 @@
         </p:nvSpPr>
         <p:spPr>
           <a:xfrm>
-            <a:off x="6180309" y="2722623"/>
-            <a:ext cx="343047" cy="132016"/>
+            <a:off x="5419512" y="2747109"/>
+            <a:ext cx="303936" cy="116928"/>
           </a:xfrm>
           <a:prstGeom prst="rect">
             <a:avLst/>
@@ -20795,7 +20795,7 @@
           <a:p>
             <a:pPr algn="ctr"/>
             <a:r>
-              <a:rPr sz="769" b="1">
+              <a:rPr sz="682" b="1">
                 <a:solidFill>
                   <a:srgbClr val="8FB1E6"/>
                 </a:solidFill>
@@ -20815,8 +20815,8 @@
         </p:nvSpPr>
         <p:spPr>
           <a:xfrm>
-            <a:off x="7689089" y="2159000"/>
-            <a:ext cx="355600" cy="355600"/>
+            <a:off x="6755908" y="2247900"/>
+            <a:ext cx="314960" cy="314960"/>
           </a:xfrm>
           <a:prstGeom prst="ellipse">
             <a:avLst/>
@@ -20824,7 +20824,7 @@
           <a:solidFill>
             <a:srgbClr val="8FB1E6"/>
           </a:solidFill>
-          <a:ln w="13334">
+          <a:ln w="11811">
             <a:solidFill>
               <a:srgbClr val="061418"/>
             </a:solidFill>
@@ -20859,8 +20859,8 @@
         </p:nvSpPr>
         <p:spPr>
           <a:xfrm>
-            <a:off x="7770091" y="2237054"/>
-            <a:ext cx="193597" cy="204025"/>
+            <a:off x="6827955" y="2317033"/>
+            <a:ext cx="170865" cy="180708"/>
           </a:xfrm>
           <a:prstGeom prst="rect">
             <a:avLst/>
@@ -20875,7 +20875,7 @@
           <a:p>
             <a:pPr algn="ctr"/>
             <a:r>
-              <a:rPr sz="1189" b="1">
+              <a:rPr sz="1054" b="1">
                 <a:solidFill>
                   <a:srgbClr val="0B1B1F"/>
                 </a:solidFill>
@@ -20895,8 +20895,8 @@
         </p:nvSpPr>
         <p:spPr>
           <a:xfrm>
-            <a:off x="7658028" y="2576829"/>
-            <a:ext cx="417723" cy="186690"/>
+            <a:off x="6728349" y="2617978"/>
+            <a:ext cx="370078" cy="165354"/>
           </a:xfrm>
           <a:prstGeom prst="roundRect">
             <a:avLst>
@@ -20906,7 +20906,7 @@
           <a:solidFill>
             <a:srgbClr val="0A2126"/>
           </a:solidFill>
-          <a:ln w="8890">
+          <a:ln w="7874">
             <a:solidFill>
               <a:srgbClr val="8FB1E6"/>
             </a:solidFill>
@@ -20941,8 +20941,8 @@
         </p:nvSpPr>
         <p:spPr>
           <a:xfrm>
-            <a:off x="7695366" y="2619324"/>
-            <a:ext cx="343047" cy="132016"/>
+            <a:off x="6761419" y="2655615"/>
+            <a:ext cx="303936" cy="116928"/>
           </a:xfrm>
           <a:prstGeom prst="rect">
             <a:avLst/>
@@ -20957,7 +20957,7 @@
           <a:p>
             <a:pPr algn="ctr"/>
             <a:r>
-              <a:rPr sz="769" b="1">
+              <a:rPr sz="682" b="1">
                 <a:solidFill>
                   <a:srgbClr val="8FB1E6"/>
                 </a:solidFill>
@@ -20977,14 +20977,14 @@
         </p:nvSpPr>
         <p:spPr>
           <a:xfrm>
-            <a:off x="7059277" y="3388574"/>
-            <a:ext cx="444500" cy="444500"/>
+            <a:off x="6198074" y="3336951"/>
+            <a:ext cx="393700" cy="393700"/>
           </a:xfrm>
           <a:prstGeom prst="ellipse">
             <a:avLst/>
           </a:prstGeom>
           <a:noFill/>
-          <a:ln w="22225">
+          <a:ln w="19685">
             <a:solidFill>
               <a:srgbClr val="D8BB78"/>
             </a:solidFill>
@@ -21019,8 +21019,8 @@
         </p:nvSpPr>
         <p:spPr>
           <a:xfrm>
-            <a:off x="7103727" y="3433024"/>
-            <a:ext cx="355600" cy="355600"/>
+            <a:off x="6237444" y="3376321"/>
+            <a:ext cx="314960" cy="314960"/>
           </a:xfrm>
           <a:prstGeom prst="ellipse">
             <a:avLst/>
@@ -21028,7 +21028,7 @@
           <a:solidFill>
             <a:srgbClr val="D8BB78"/>
           </a:solidFill>
-          <a:ln w="13334">
+          <a:ln w="11811">
             <a:solidFill>
               <a:srgbClr val="061418"/>
             </a:solidFill>
@@ -21063,8 +21063,8 @@
         </p:nvSpPr>
         <p:spPr>
           <a:xfrm>
-            <a:off x="7186617" y="3511078"/>
-            <a:ext cx="189819" cy="204025"/>
+            <a:off x="6311459" y="3445455"/>
+            <a:ext cx="166928" cy="180708"/>
           </a:xfrm>
           <a:prstGeom prst="rect">
             <a:avLst/>
@@ -21079,7 +21079,7 @@
           <a:p>
             <a:pPr algn="ctr"/>
             <a:r>
-              <a:rPr sz="1189" b="1">
+              <a:rPr sz="1054" b="1">
                 <a:solidFill>
                   <a:srgbClr val="0B1B1F"/>
                 </a:solidFill>
@@ -21099,8 +21099,8 @@
         </p:nvSpPr>
         <p:spPr>
           <a:xfrm>
-            <a:off x="7073887" y="3850854"/>
-            <a:ext cx="415278" cy="186690"/>
+            <a:off x="6211853" y="3746399"/>
+            <a:ext cx="366141" cy="165354"/>
           </a:xfrm>
           <a:prstGeom prst="roundRect">
             <a:avLst>
@@ -21110,7 +21110,7 @@
           <a:solidFill>
             <a:srgbClr val="0A2126"/>
           </a:solidFill>
-          <a:ln w="8890">
+          <a:ln w="7874">
             <a:solidFill>
               <a:srgbClr val="D8BB78"/>
             </a:solidFill>
@@ -21145,8 +21145,8 @@
         </p:nvSpPr>
         <p:spPr>
           <a:xfrm>
-            <a:off x="7111225" y="3893348"/>
-            <a:ext cx="340602" cy="132016"/>
+            <a:off x="6244924" y="3784037"/>
+            <a:ext cx="299999" cy="116928"/>
           </a:xfrm>
           <a:prstGeom prst="rect">
             <a:avLst/>
@@ -21161,7 +21161,7 @@
           <a:p>
             <a:pPr algn="ctr"/>
             <a:r>
-              <a:rPr sz="769" b="1">
+              <a:rPr sz="682" b="1">
                 <a:solidFill>
                   <a:srgbClr val="D8BB78"/>
                 </a:solidFill>
@@ -21181,8 +21181,8 @@
         </p:nvSpPr>
         <p:spPr>
           <a:xfrm>
-            <a:off x="8653216" y="4156119"/>
-            <a:ext cx="355600" cy="355600"/>
+            <a:off x="7609848" y="4016777"/>
+            <a:ext cx="314960" cy="314960"/>
           </a:xfrm>
           <a:prstGeom prst="ellipse">
             <a:avLst/>
@@ -21190,7 +21190,7 @@
           <a:solidFill>
             <a:srgbClr val="C2A6E6"/>
           </a:solidFill>
-          <a:ln w="13334">
+          <a:ln w="11811">
             <a:solidFill>
               <a:srgbClr val="061418"/>
             </a:solidFill>
@@ -21225,8 +21225,8 @@
         </p:nvSpPr>
         <p:spPr>
           <a:xfrm>
-            <a:off x="8731724" y="4234173"/>
-            <a:ext cx="198584" cy="204025"/>
+            <a:off x="7679927" y="4085911"/>
+            <a:ext cx="174802" cy="180708"/>
           </a:xfrm>
           <a:prstGeom prst="rect">
             <a:avLst/>
@@ -21241,7 +21241,7 @@
           <a:p>
             <a:pPr algn="ctr"/>
             <a:r>
-              <a:rPr sz="1189" b="1">
+              <a:rPr sz="1054" b="1">
                 <a:solidFill>
                   <a:srgbClr val="0B1B1F"/>
                 </a:solidFill>
@@ -21261,8 +21261,8 @@
         </p:nvSpPr>
         <p:spPr>
           <a:xfrm>
-            <a:off x="8620541" y="4573949"/>
-            <a:ext cx="420950" cy="186690"/>
+            <a:off x="7580321" y="4386855"/>
+            <a:ext cx="374015" cy="165354"/>
           </a:xfrm>
           <a:prstGeom prst="roundRect">
             <a:avLst>
@@ -21272,7 +21272,7 @@
           <a:solidFill>
             <a:srgbClr val="0A2126"/>
           </a:solidFill>
-          <a:ln w="8890">
+          <a:ln w="7874">
             <a:solidFill>
               <a:srgbClr val="C2A6E6"/>
             </a:solidFill>
@@ -21307,8 +21307,8 @@
         </p:nvSpPr>
         <p:spPr>
           <a:xfrm>
-            <a:off x="8657879" y="4616443"/>
-            <a:ext cx="346274" cy="132016"/>
+            <a:off x="7613392" y="4424493"/>
+            <a:ext cx="307873" cy="116928"/>
           </a:xfrm>
           <a:prstGeom prst="rect">
             <a:avLst/>
@@ -21323,7 +21323,7 @@
           <a:p>
             <a:pPr algn="ctr"/>
             <a:r>
-              <a:rPr sz="769" b="1">
+              <a:rPr sz="682" b="1">
                 <a:solidFill>
                   <a:srgbClr val="C2A6E6"/>
                 </a:solidFill>
@@ -21343,8 +21343,8 @@
         </p:nvSpPr>
         <p:spPr>
           <a:xfrm>
-            <a:off x="6931561" y="4603750"/>
-            <a:ext cx="355600" cy="355600"/>
+            <a:off x="6084954" y="4413250"/>
+            <a:ext cx="314960" cy="314960"/>
           </a:xfrm>
           <a:prstGeom prst="ellipse">
             <a:avLst/>
@@ -21352,7 +21352,7 @@
           <a:solidFill>
             <a:srgbClr val="E39FB8"/>
           </a:solidFill>
-          <a:ln w="13334">
+          <a:ln w="11811">
             <a:solidFill>
               <a:srgbClr val="061418"/>
             </a:solidFill>
@@ -21387,8 +21387,8 @@
         </p:nvSpPr>
         <p:spPr>
           <a:xfrm>
-            <a:off x="7017550" y="4681804"/>
-            <a:ext cx="183622" cy="204025"/>
+            <a:off x="6160938" y="4482383"/>
+            <a:ext cx="162991" cy="180708"/>
           </a:xfrm>
           <a:prstGeom prst="rect">
             <a:avLst/>
@@ -21403,7 +21403,7 @@
           <a:p>
             <a:pPr algn="ctr"/>
             <a:r>
-              <a:rPr sz="1189" b="1">
+              <a:rPr sz="1054" b="1">
                 <a:solidFill>
                   <a:srgbClr val="0B1B1F"/>
                 </a:solidFill>
@@ -21423,8 +21423,8 @@
         </p:nvSpPr>
         <p:spPr>
           <a:xfrm>
-            <a:off x="6903727" y="5021580"/>
-            <a:ext cx="411269" cy="186690"/>
+            <a:off x="6059364" y="4783328"/>
+            <a:ext cx="366141" cy="165354"/>
           </a:xfrm>
           <a:prstGeom prst="roundRect">
             <a:avLst>
@@ -21434,7 +21434,7 @@
           <a:solidFill>
             <a:srgbClr val="0A2126"/>
           </a:solidFill>
-          <a:ln w="8890">
+          <a:ln w="7874">
             <a:solidFill>
               <a:srgbClr val="E39FB8"/>
             </a:solidFill>
@@ -21469,8 +21469,8 @@
         </p:nvSpPr>
         <p:spPr>
           <a:xfrm>
-            <a:off x="6941065" y="5064074"/>
-            <a:ext cx="336593" cy="132016"/>
+            <a:off x="6092434" y="4820965"/>
+            <a:ext cx="299999" cy="116928"/>
           </a:xfrm>
           <a:prstGeom prst="rect">
             <a:avLst/>
@@ -21485,7 +21485,7 @@
           <a:p>
             <a:pPr algn="ctr"/>
             <a:r>
-              <a:rPr sz="769" b="1">
+              <a:rPr sz="682" b="1">
                 <a:solidFill>
                   <a:srgbClr val="E39FB8"/>
                 </a:solidFill>
@@ -21556,7 +21556,7 @@
         <p:spPr>
           <a:xfrm>
             <a:off x="8665210" y="2206244"/>
-            <a:ext cx="1516100" cy="240030"/>
+            <a:ext cx="1510030" cy="240030"/>
           </a:xfrm>
           <a:prstGeom prst="rect">
             <a:avLst/>
@@ -21592,7 +21592,7 @@
         <p:spPr>
           <a:xfrm>
             <a:off x="8689975" y="2599690"/>
-            <a:ext cx="663130" cy="257175"/>
+            <a:ext cx="666750" cy="257175"/>
           </a:xfrm>
           <a:prstGeom prst="rect">
             <a:avLst/>
@@ -21715,8 +21715,8 @@
         </p:nvSpPr>
         <p:spPr>
           <a:xfrm>
-            <a:off x="11618849" y="2573782"/>
-            <a:ext cx="256920" cy="291465"/>
+            <a:off x="11619230" y="2573782"/>
+            <a:ext cx="256540" cy="291465"/>
           </a:xfrm>
           <a:prstGeom prst="rect">
             <a:avLst/>
@@ -21752,7 +21752,7 @@
         <p:spPr>
           <a:xfrm>
             <a:off x="8689975" y="3107690"/>
-            <a:ext cx="669036" cy="257175"/>
+            <a:ext cx="673100" cy="257175"/>
           </a:xfrm>
           <a:prstGeom prst="rect">
             <a:avLst/>
@@ -21875,8 +21875,8 @@
         </p:nvSpPr>
         <p:spPr>
           <a:xfrm>
-            <a:off x="11618849" y="3081782"/>
-            <a:ext cx="256920" cy="291465"/>
+            <a:off x="11619230" y="3081782"/>
+            <a:ext cx="256540" cy="291465"/>
           </a:xfrm>
           <a:prstGeom prst="rect">
             <a:avLst/>
@@ -21912,7 +21912,7 @@
         <p:spPr>
           <a:xfrm>
             <a:off x="8689975" y="3615690"/>
-            <a:ext cx="650176" cy="257175"/>
+            <a:ext cx="654050" cy="257175"/>
           </a:xfrm>
           <a:prstGeom prst="rect">
             <a:avLst/>
@@ -21948,7 +21948,7 @@
         <p:spPr>
           <a:xfrm>
             <a:off x="9588500" y="3670300"/>
-            <a:ext cx="1600199" cy="139700"/>
+            <a:ext cx="1778000" cy="139700"/>
           </a:xfrm>
           <a:prstGeom prst="roundRect">
             <a:avLst>
@@ -21992,7 +21992,7 @@
         <p:spPr>
           <a:xfrm>
             <a:off x="9588500" y="3670300"/>
-            <a:ext cx="320040" cy="139700"/>
+            <a:ext cx="355600" cy="139700"/>
           </a:xfrm>
           <a:prstGeom prst="roundRect">
             <a:avLst>
@@ -22035,8 +22035,8 @@
         </p:nvSpPr>
         <p:spPr>
           <a:xfrm>
-            <a:off x="11618849" y="3589782"/>
-            <a:ext cx="256920" cy="291465"/>
+            <a:off x="11619230" y="3589782"/>
+            <a:ext cx="256540" cy="291465"/>
           </a:xfrm>
           <a:prstGeom prst="rect">
             <a:avLst/>
@@ -22289,7 +22289,7 @@
         <p:spPr>
           <a:xfrm>
             <a:off x="563880" y="6512052"/>
-            <a:ext cx="1655826" cy="205740"/>
+            <a:ext cx="1647189" cy="205740"/>
           </a:xfrm>
           <a:prstGeom prst="rect">
             <a:avLst/>
@@ -22324,8 +22324,8 @@
         </p:nvSpPr>
         <p:spPr>
           <a:xfrm>
-            <a:off x="11108524" y="6499098"/>
-            <a:ext cx="561505" cy="222885"/>
+            <a:off x="11113770" y="6499098"/>
+            <a:ext cx="556260" cy="222885"/>
           </a:xfrm>
           <a:prstGeom prst="rect">
             <a:avLst/>
@@ -22360,8 +22360,8 @@
         </p:nvSpPr>
         <p:spPr>
           <a:xfrm>
-            <a:off x="9601809" y="377952"/>
-            <a:ext cx="2064410" cy="205740"/>
+            <a:off x="9307830" y="377952"/>
+            <a:ext cx="2358390" cy="205740"/>
           </a:xfrm>
           <a:prstGeom prst="rect">
             <a:avLst/>
@@ -22383,7 +22383,7 @@
                 <a:latin typeface="Noto Sans SC"/>
                 <a:ea typeface="Noto Sans SC"/>
               </a:rPr>
-              <a:t>影片 《圈子从哪里来》 01:36</a:t>
+              <a:t>影片 《精讲：规则与停止》 00:59</a:t>
             </a:r>
           </a:p>
         </p:txBody>
@@ -22914,7 +22914,7 @@
         </p:nvSpPr>
         <p:spPr>
           <a:xfrm>
-            <a:off x="9960610" y="1660144"/>
+            <a:off x="10151110" y="1660144"/>
             <a:ext cx="462280" cy="240030"/>
           </a:xfrm>
           <a:prstGeom prst="rect">
@@ -22951,7 +22951,7 @@
         <p:spPr>
           <a:xfrm>
             <a:off x="6057900" y="1943100"/>
-            <a:ext cx="4673600" cy="0"/>
+            <a:ext cx="4864100" cy="0"/>
           </a:xfrm>
           <a:prstGeom prst="line">
             <a:avLst/>
@@ -22986,7 +22986,7 @@
         <p:spPr>
           <a:xfrm>
             <a:off x="6085840" y="2116836"/>
-            <a:ext cx="245465" cy="274320"/>
+            <a:ext cx="242570" cy="274320"/>
           </a:xfrm>
           <a:prstGeom prst="rect">
             <a:avLst/>
@@ -23022,7 +23022,7 @@
         <p:spPr>
           <a:xfrm>
             <a:off x="6784340" y="2116836"/>
-            <a:ext cx="926795" cy="274320"/>
+            <a:ext cx="928369" cy="274320"/>
           </a:xfrm>
           <a:prstGeom prst="rect">
             <a:avLst/>
@@ -23058,7 +23058,7 @@
         <p:spPr>
           <a:xfrm>
             <a:off x="8879840" y="2116836"/>
-            <a:ext cx="255422" cy="274320"/>
+            <a:ext cx="255270" cy="274320"/>
           </a:xfrm>
           <a:prstGeom prst="rect">
             <a:avLst/>
@@ -23093,7 +23093,7 @@
         </p:nvSpPr>
         <p:spPr>
           <a:xfrm>
-            <a:off x="9959340" y="2116836"/>
+            <a:off x="10149840" y="2116836"/>
             <a:ext cx="325120" cy="274320"/>
           </a:xfrm>
           <a:prstGeom prst="rect">
@@ -23130,7 +23130,7 @@
         <p:spPr>
           <a:xfrm>
             <a:off x="6085840" y="2599436"/>
-            <a:ext cx="255422" cy="274320"/>
+            <a:ext cx="255270" cy="274320"/>
           </a:xfrm>
           <a:prstGeom prst="rect">
             <a:avLst/>
@@ -23166,7 +23166,7 @@
         <p:spPr>
           <a:xfrm>
             <a:off x="6784340" y="2599436"/>
-            <a:ext cx="926795" cy="274320"/>
+            <a:ext cx="928369" cy="274320"/>
           </a:xfrm>
           <a:prstGeom prst="rect">
             <a:avLst/>
@@ -23202,7 +23202,7 @@
         <p:spPr>
           <a:xfrm>
             <a:off x="8879840" y="2599436"/>
-            <a:ext cx="255422" cy="274320"/>
+            <a:ext cx="255270" cy="274320"/>
           </a:xfrm>
           <a:prstGeom prst="rect">
             <a:avLst/>
@@ -23237,7 +23237,7 @@
         </p:nvSpPr>
         <p:spPr>
           <a:xfrm>
-            <a:off x="9959340" y="2599436"/>
+            <a:off x="10149840" y="2599436"/>
             <a:ext cx="325120" cy="274320"/>
           </a:xfrm>
           <a:prstGeom prst="rect">
@@ -23274,7 +23274,7 @@
         <p:spPr>
           <a:xfrm>
             <a:off x="6085840" y="3082036"/>
-            <a:ext cx="251561" cy="274320"/>
+            <a:ext cx="248920" cy="274320"/>
           </a:xfrm>
           <a:prstGeom prst="rect">
             <a:avLst/>
@@ -23310,7 +23310,7 @@
         <p:spPr>
           <a:xfrm>
             <a:off x="6784340" y="3082036"/>
-            <a:ext cx="1429105" cy="274320"/>
+            <a:ext cx="1436370" cy="274320"/>
           </a:xfrm>
           <a:prstGeom prst="rect">
             <a:avLst/>
@@ -23346,7 +23346,7 @@
         <p:spPr>
           <a:xfrm>
             <a:off x="8879840" y="3082036"/>
-            <a:ext cx="255422" cy="274320"/>
+            <a:ext cx="255270" cy="274320"/>
           </a:xfrm>
           <a:prstGeom prst="rect">
             <a:avLst/>
@@ -23381,7 +23381,7 @@
         </p:nvSpPr>
         <p:spPr>
           <a:xfrm>
-            <a:off x="9959340" y="3082036"/>
+            <a:off x="10149840" y="3082036"/>
             <a:ext cx="325120" cy="274320"/>
           </a:xfrm>
           <a:prstGeom prst="rect">
@@ -23418,7 +23418,7 @@
         <p:spPr>
           <a:xfrm>
             <a:off x="6085840" y="3564636"/>
-            <a:ext cx="261721" cy="274320"/>
+            <a:ext cx="261620" cy="274320"/>
           </a:xfrm>
           <a:prstGeom prst="rect">
             <a:avLst/>
@@ -23454,7 +23454,7 @@
         <p:spPr>
           <a:xfrm>
             <a:off x="6784340" y="3564636"/>
-            <a:ext cx="916838" cy="274320"/>
+            <a:ext cx="922019" cy="274320"/>
           </a:xfrm>
           <a:prstGeom prst="rect">
             <a:avLst/>
@@ -23490,7 +23490,7 @@
         <p:spPr>
           <a:xfrm>
             <a:off x="8879840" y="3564636"/>
-            <a:ext cx="241604" cy="274320"/>
+            <a:ext cx="242570" cy="274320"/>
           </a:xfrm>
           <a:prstGeom prst="rect">
             <a:avLst/>
@@ -23525,7 +23525,7 @@
         </p:nvSpPr>
         <p:spPr>
           <a:xfrm>
-            <a:off x="9959340" y="3564636"/>
+            <a:off x="10149840" y="3564636"/>
             <a:ext cx="325120" cy="274320"/>
           </a:xfrm>
           <a:prstGeom prst="rect">
@@ -23562,7 +23562,7 @@
         <p:spPr>
           <a:xfrm>
             <a:off x="6085840" y="4047236"/>
-            <a:ext cx="241604" cy="274320"/>
+            <a:ext cx="242570" cy="274320"/>
           </a:xfrm>
           <a:prstGeom prst="rect">
             <a:avLst/>
@@ -23598,7 +23598,7 @@
         <p:spPr>
           <a:xfrm>
             <a:off x="6784340" y="4047236"/>
-            <a:ext cx="916838" cy="274320"/>
+            <a:ext cx="922019" cy="274320"/>
           </a:xfrm>
           <a:prstGeom prst="rect">
             <a:avLst/>
@@ -23634,7 +23634,7 @@
         <p:spPr>
           <a:xfrm>
             <a:off x="8879840" y="4047236"/>
-            <a:ext cx="241604" cy="274320"/>
+            <a:ext cx="242570" cy="274320"/>
           </a:xfrm>
           <a:prstGeom prst="rect">
             <a:avLst/>
@@ -23669,7 +23669,7 @@
         </p:nvSpPr>
         <p:spPr>
           <a:xfrm>
-            <a:off x="9959340" y="4047236"/>
+            <a:off x="10149840" y="4047236"/>
             <a:ext cx="325120" cy="274320"/>
           </a:xfrm>
           <a:prstGeom prst="rect">
@@ -23705,8 +23705,8 @@
         </p:nvSpPr>
         <p:spPr>
           <a:xfrm>
-            <a:off x="6966381" y="4991100"/>
-            <a:ext cx="2958236" cy="292100"/>
+            <a:off x="6965950" y="4991100"/>
+            <a:ext cx="2959100" cy="292100"/>
           </a:xfrm>
           <a:prstGeom prst="roundRect">
             <a:avLst>
@@ -23751,8 +23751,8 @@
         </p:nvSpPr>
         <p:spPr>
           <a:xfrm>
-            <a:off x="7012101" y="5051298"/>
-            <a:ext cx="2866796" cy="222885"/>
+            <a:off x="7011670" y="5051298"/>
+            <a:ext cx="2867660" cy="222885"/>
           </a:xfrm>
           <a:prstGeom prst="rect">
             <a:avLst/>
@@ -24005,7 +24005,7 @@
         <p:spPr>
           <a:xfrm>
             <a:off x="563880" y="6512052"/>
-            <a:ext cx="1655826" cy="205740"/>
+            <a:ext cx="1647189" cy="205740"/>
           </a:xfrm>
           <a:prstGeom prst="rect">
             <a:avLst/>
@@ -24040,8 +24040,8 @@
         </p:nvSpPr>
         <p:spPr>
           <a:xfrm>
-            <a:off x="11108524" y="6499098"/>
-            <a:ext cx="561505" cy="222885"/>
+            <a:off x="11113770" y="6499098"/>
+            <a:ext cx="556260" cy="222885"/>
           </a:xfrm>
           <a:prstGeom prst="rect">
             <a:avLst/>
@@ -24076,8 +24076,8 @@
         </p:nvSpPr>
         <p:spPr>
           <a:xfrm>
-            <a:off x="9601809" y="377952"/>
-            <a:ext cx="2064410" cy="205740"/>
+            <a:off x="9307830" y="377952"/>
+            <a:ext cx="2358390" cy="205740"/>
           </a:xfrm>
           <a:prstGeom prst="rect">
             <a:avLst/>
@@ -24099,7 +24099,7 @@
                 <a:latin typeface="Noto Sans SC"/>
                 <a:ea typeface="Noto Sans SC"/>
               </a:rPr>
-              <a:t>影片 《圈子从哪里来》 01:52</a:t>
+              <a:t>影片 《精讲：规则与停止》 01:48</a:t>
             </a:r>
           </a:p>
         </p:txBody>
@@ -24522,13 +24522,13 @@
         </p:nvCxnSpPr>
         <p:spPr>
           <a:xfrm>
-            <a:off x="6959600" y="2781300"/>
-            <a:ext cx="3048000" cy="0"/>
+            <a:off x="6731000" y="2667000"/>
+            <a:ext cx="3810000" cy="0"/>
           </a:xfrm>
           <a:prstGeom prst="line">
             <a:avLst/>
           </a:prstGeom>
-          <a:ln w="15240">
+          <a:ln w="25400">
             <a:solidFill>
               <a:srgbClr val="DB7B72"/>
             </a:solidFill>
@@ -24558,8 +24558,8 @@
         </p:nvSpPr>
         <p:spPr>
           <a:xfrm>
-            <a:off x="8395817" y="2560624"/>
-            <a:ext cx="175564" cy="175564"/>
+            <a:off x="8489696" y="2299208"/>
+            <a:ext cx="292608" cy="292608"/>
           </a:xfrm>
           <a:prstGeom prst="ellipse">
             <a:avLst/>
@@ -24602,8 +24602,8 @@
         </p:nvSpPr>
         <p:spPr>
           <a:xfrm>
-            <a:off x="8411057" y="2565501"/>
-            <a:ext cx="145084" cy="164592"/>
+            <a:off x="8514715" y="2307336"/>
+            <a:ext cx="242570" cy="274320"/>
           </a:xfrm>
           <a:prstGeom prst="rect">
             <a:avLst/>
@@ -24618,7 +24618,7 @@
           <a:p>
             <a:pPr algn="ctr"/>
             <a:r>
-              <a:rPr sz="960" b="1">
+              <a:rPr sz="1600" b="1">
                 <a:solidFill>
                   <a:srgbClr val="D9E4E1"/>
                 </a:solidFill>
@@ -24638,16 +24638,16 @@
         </p:nvSpPr>
         <p:spPr>
           <a:xfrm>
-            <a:off x="6715759" y="2537460"/>
-            <a:ext cx="487680" cy="487680"/>
+            <a:off x="6375400" y="2311400"/>
+            <a:ext cx="711200" cy="711200"/>
           </a:xfrm>
           <a:prstGeom prst="ellipse">
             <a:avLst/>
           </a:prstGeom>
           <a:solidFill>
-            <a:srgbClr val="77CDBB"/>
+            <a:srgbClr val="8FB1E6"/>
           </a:solidFill>
-          <a:ln w="11429">
+          <a:ln w="19050">
             <a:solidFill>
               <a:srgbClr val="061418"/>
             </a:solidFill>
@@ -24682,8 +24682,8 @@
         </p:nvSpPr>
         <p:spPr>
           <a:xfrm>
-            <a:off x="6854908" y="2670657"/>
-            <a:ext cx="209382" cy="226314"/>
+            <a:off x="6572250" y="2499360"/>
+            <a:ext cx="317500" cy="342900"/>
           </a:xfrm>
           <a:prstGeom prst="rect">
             <a:avLst/>
@@ -24698,7 +24698,7 @@
           <a:p>
             <a:pPr algn="ctr"/>
             <a:r>
-              <a:rPr sz="1320" b="1">
+              <a:rPr sz="2000" b="1">
                 <a:solidFill>
                   <a:srgbClr val="0B1B1F"/>
                 </a:solidFill>
@@ -24718,8 +24718,8 @@
         </p:nvSpPr>
         <p:spPr>
           <a:xfrm>
-            <a:off x="6738086" y="3131820"/>
-            <a:ext cx="443026" cy="190500"/>
+            <a:off x="6292850" y="3149600"/>
+            <a:ext cx="876300" cy="292100"/>
           </a:xfrm>
           <a:prstGeom prst="roundRect">
             <a:avLst>
@@ -24729,9 +24729,9 @@
           <a:solidFill>
             <a:srgbClr val="0A2126"/>
           </a:solidFill>
-          <a:ln w="7620">
+          <a:ln w="12700">
             <a:solidFill>
-              <a:srgbClr val="77CDBB"/>
+              <a:srgbClr val="8FB1E6"/>
             </a:solidFill>
           </a:ln>
           <a:effectLst/>
@@ -24764,8 +24764,8 @@
         </p:nvSpPr>
         <p:spPr>
           <a:xfrm>
-            <a:off x="6760946" y="3167634"/>
-            <a:ext cx="397306" cy="154305"/>
+            <a:off x="6338570" y="3209798"/>
+            <a:ext cx="784860" cy="222885"/>
           </a:xfrm>
           <a:prstGeom prst="rect">
             <a:avLst/>
@@ -24780,14 +24780,14 @@
           <a:p>
             <a:pPr algn="ctr"/>
             <a:r>
-              <a:rPr sz="900" b="1">
+              <a:rPr sz="1300" b="1">
                 <a:solidFill>
-                  <a:srgbClr val="77CDBB"/>
+                  <a:srgbClr val="8FB1E6"/>
                 </a:solidFill>
                 <a:latin typeface="Noto Sans SC"/>
                 <a:ea typeface="Noto Sans SC"/>
               </a:rPr>
-              <a:t>标签 A</a:t>
+              <a:t>标签 B ⇄</a:t>
             </a:r>
           </a:p>
         </p:txBody>
@@ -24800,16 +24800,16 @@
         </p:nvSpPr>
         <p:spPr>
           <a:xfrm>
-            <a:off x="9763760" y="2537460"/>
-            <a:ext cx="487680" cy="487680"/>
+            <a:off x="10185400" y="2311400"/>
+            <a:ext cx="711200" cy="711200"/>
           </a:xfrm>
           <a:prstGeom prst="ellipse">
             <a:avLst/>
           </a:prstGeom>
           <a:solidFill>
-            <a:srgbClr val="8FB1E6"/>
+            <a:srgbClr val="77CDBB"/>
           </a:solidFill>
-          <a:ln w="11429">
+          <a:ln w="19050">
             <a:solidFill>
               <a:srgbClr val="061418"/>
             </a:solidFill>
@@ -24844,8 +24844,8 @@
         </p:nvSpPr>
         <p:spPr>
           <a:xfrm>
-            <a:off x="9900226" y="2670657"/>
-            <a:ext cx="214746" cy="226314"/>
+            <a:off x="10379075" y="2499360"/>
+            <a:ext cx="323850" cy="342900"/>
           </a:xfrm>
           <a:prstGeom prst="rect">
             <a:avLst/>
@@ -24860,7 +24860,7 @@
           <a:p>
             <a:pPr algn="ctr"/>
             <a:r>
-              <a:rPr sz="1320" b="1">
+              <a:rPr sz="2000" b="1">
                 <a:solidFill>
                   <a:srgbClr val="0B1B1F"/>
                 </a:solidFill>
@@ -24880,8 +24880,8 @@
         </p:nvSpPr>
         <p:spPr>
           <a:xfrm>
-            <a:off x="9784257" y="3131820"/>
-            <a:ext cx="446684" cy="190500"/>
+            <a:off x="10106025" y="3149600"/>
+            <a:ext cx="869950" cy="292100"/>
           </a:xfrm>
           <a:prstGeom prst="roundRect">
             <a:avLst>
@@ -24891,9 +24891,9 @@
           <a:solidFill>
             <a:srgbClr val="0A2126"/>
           </a:solidFill>
-          <a:ln w="7620">
+          <a:ln w="12700">
             <a:solidFill>
-              <a:srgbClr val="8FB1E6"/>
+              <a:srgbClr val="77CDBB"/>
             </a:solidFill>
           </a:ln>
           <a:effectLst/>
@@ -24926,8 +24926,8 @@
         </p:nvSpPr>
         <p:spPr>
           <a:xfrm>
-            <a:off x="9807117" y="3167634"/>
-            <a:ext cx="400964" cy="154305"/>
+            <a:off x="10151745" y="3209798"/>
+            <a:ext cx="778510" cy="222885"/>
           </a:xfrm>
           <a:prstGeom prst="rect">
             <a:avLst/>
@@ -24942,14 +24942,14 @@
           <a:p>
             <a:pPr algn="ctr"/>
             <a:r>
-              <a:rPr sz="900" b="1">
+              <a:rPr sz="1300" b="1">
                 <a:solidFill>
-                  <a:srgbClr val="8FB1E6"/>
+                  <a:srgbClr val="77CDBB"/>
                 </a:solidFill>
                 <a:latin typeface="Noto Sans SC"/>
                 <a:ea typeface="Noto Sans SC"/>
               </a:rPr>
-              <a:t>标签 B</a:t>
+              <a:t>标签 A ⇄</a:t>
             </a:r>
           </a:p>
         </p:txBody>
@@ -24962,8 +24962,8 @@
         </p:nvSpPr>
         <p:spPr>
           <a:xfrm>
-            <a:off x="7214108" y="1963369"/>
-            <a:ext cx="2538984" cy="174879"/>
+            <a:off x="7355840" y="1634236"/>
+            <a:ext cx="2560320" cy="274320"/>
           </a:xfrm>
           <a:prstGeom prst="rect">
             <a:avLst/>
@@ -24978,14 +24978,14 @@
           <a:p>
             <a:pPr algn="ctr"/>
             <a:r>
-              <a:rPr sz="1019" b="0">
+              <a:rPr sz="1600" b="0">
                 <a:solidFill>
                   <a:srgbClr val="D8BB78"/>
                 </a:solidFill>
                 <a:latin typeface="Noto Sans SC"/>
                 <a:ea typeface="Noto Sans SC"/>
               </a:rPr>
-              <a:t>同步：大家读同一张旧快照，轮末一起提交</a:t>
+              <a:t>同步：两节点每轮交换标签</a:t>
             </a:r>
           </a:p>
         </p:txBody>
@@ -24998,125 +24998,7 @@
         </p:nvSpPr>
         <p:spPr>
           <a:xfrm>
-            <a:off x="8277688" y="3731514"/>
-            <a:ext cx="411822" cy="154305"/>
-          </a:xfrm>
-          <a:prstGeom prst="rect">
-            <a:avLst/>
-          </a:prstGeom>
-          <a:noFill/>
-        </p:spPr>
-        <p:txBody>
-          <a:bodyPr wrap="none" lIns="0" rIns="0" tIns="0" bIns="0">
-            <a:spAutoFit/>
-          </a:bodyPr>
-          <a:lstStyle/>
-          <a:p>
-            <a:pPr algn="ctr"/>
-            <a:r>
-              <a:rPr sz="900" b="0">
-                <a:solidFill>
-                  <a:srgbClr val="BCD2D0"/>
-                </a:solidFill>
-                <a:latin typeface="Noto Sans SC"/>
-                <a:ea typeface="Noto Sans SC"/>
-              </a:rPr>
-              <a:t>第 2 轮</a:t>
-            </a:r>
-          </a:p>
-        </p:txBody>
-      </p:sp>
-      <p:sp>
-        <p:nvSpPr>
-          <p:cNvPr id="33" name="Rounded Rectangle 32"/>
-          <p:cNvSpPr/>
-          <p:nvPr/>
-        </p:nvSpPr>
-        <p:spPr>
-          <a:xfrm>
-            <a:off x="7021531" y="4023359"/>
-            <a:ext cx="2924136" cy="175260"/>
-          </a:xfrm>
-          <a:prstGeom prst="roundRect">
-            <a:avLst>
-              <a:gd name="adj" fmla="val 50000"/>
-            </a:avLst>
-          </a:prstGeom>
-          <a:solidFill>
-            <a:srgbClr val="0A2126"/>
-          </a:solidFill>
-          <a:ln w="7620">
-            <a:solidFill>
-              <a:srgbClr val="DB7B72"/>
-            </a:solidFill>
-          </a:ln>
-          <a:effectLst/>
-        </p:spPr>
-        <p:style>
-          <a:lnRef idx="1">
-            <a:schemeClr val="accent1"/>
-          </a:lnRef>
-          <a:fillRef idx="3">
-            <a:schemeClr val="accent1"/>
-          </a:fillRef>
-          <a:effectRef idx="2">
-            <a:schemeClr val="accent1"/>
-          </a:effectRef>
-          <a:fontRef idx="minor">
-            <a:schemeClr val="lt1"/>
-          </a:fontRef>
-        </p:style>
-        <p:txBody>
-          <a:bodyPr rtlCol="0" anchor="ctr"/>
-          <a:lstStyle/>
-          <a:p/>
-        </p:txBody>
-      </p:sp>
-      <p:sp>
-        <p:nvSpPr>
-          <p:cNvPr id="34" name="TextBox 33"/>
-          <p:cNvSpPr txBox="1"/>
-          <p:nvPr/>
-        </p:nvSpPr>
-        <p:spPr>
-          <a:xfrm>
-            <a:off x="7048963" y="4059478"/>
-            <a:ext cx="2869272" cy="133731"/>
-          </a:xfrm>
-          <a:prstGeom prst="rect">
-            <a:avLst/>
-          </a:prstGeom>
-          <a:noFill/>
-        </p:spPr>
-        <p:txBody>
-          <a:bodyPr wrap="none" lIns="0" rIns="0" tIns="0" bIns="0">
-            <a:spAutoFit/>
-          </a:bodyPr>
-          <a:lstStyle/>
-          <a:p>
-            <a:pPr algn="ctr"/>
-            <a:r>
-              <a:rPr sz="780" b="1">
-                <a:solidFill>
-                  <a:srgbClr val="DB7B72"/>
-                </a:solidFill>
-                <a:latin typeface="Noto Sans SC"/>
-                <a:ea typeface="Noto Sans SC"/>
-              </a:rPr>
-              <a:t>状态重复 → cycle（G01 同步也会以周期 2 振荡，cut 停在 17）</a:t>
-            </a:r>
-          </a:p>
-        </p:txBody>
-      </p:sp>
-      <p:sp>
-        <p:nvSpPr>
-          <p:cNvPr id="35" name="TextBox 34"/>
-          <p:cNvSpPr txBox="1"/>
-          <p:nvPr/>
-        </p:nvSpPr>
-        <p:spPr>
-          <a:xfrm>
-            <a:off x="6342380" y="4416552"/>
+            <a:off x="6342380" y="4162552"/>
             <a:ext cx="243840" cy="205740"/>
           </a:xfrm>
           <a:prstGeom prst="rect">
@@ -25146,14 +25028,14 @@
       </p:sp>
       <p:sp>
         <p:nvSpPr>
-          <p:cNvPr id="36" name="TextBox 35"/>
+          <p:cNvPr id="33" name="TextBox 32"/>
           <p:cNvSpPr txBox="1"/>
           <p:nvPr/>
         </p:nvSpPr>
         <p:spPr>
           <a:xfrm>
-            <a:off x="6977380" y="4416552"/>
-            <a:ext cx="190347" cy="205740"/>
+            <a:off x="7104380" y="4162552"/>
+            <a:ext cx="186690" cy="205740"/>
           </a:xfrm>
           <a:prstGeom prst="rect">
             <a:avLst/>
@@ -25182,14 +25064,14 @@
       </p:sp>
       <p:sp>
         <p:nvSpPr>
-          <p:cNvPr id="37" name="TextBox 36"/>
+          <p:cNvPr id="34" name="TextBox 33"/>
           <p:cNvSpPr txBox="1"/>
           <p:nvPr/>
         </p:nvSpPr>
         <p:spPr>
           <a:xfrm>
-            <a:off x="7675880" y="4416552"/>
-            <a:ext cx="195224" cy="205740"/>
+            <a:off x="7802880" y="4162552"/>
+            <a:ext cx="193040" cy="205740"/>
           </a:xfrm>
           <a:prstGeom prst="rect">
             <a:avLst/>
@@ -25218,14 +25100,14 @@
       </p:sp>
       <p:sp>
         <p:nvSpPr>
-          <p:cNvPr id="38" name="TextBox 37"/>
+          <p:cNvPr id="35" name="TextBox 34"/>
           <p:cNvSpPr txBox="1"/>
           <p:nvPr/>
         </p:nvSpPr>
         <p:spPr>
           <a:xfrm>
-            <a:off x="8374380" y="4416552"/>
-            <a:ext cx="191414" cy="205740"/>
+            <a:off x="8501380" y="4162552"/>
+            <a:ext cx="193040" cy="205740"/>
           </a:xfrm>
           <a:prstGeom prst="rect">
             <a:avLst/>
@@ -25254,14 +25136,14 @@
       </p:sp>
       <p:sp>
         <p:nvSpPr>
-          <p:cNvPr id="39" name="TextBox 38"/>
+          <p:cNvPr id="36" name="TextBox 35"/>
           <p:cNvSpPr txBox="1"/>
           <p:nvPr/>
         </p:nvSpPr>
         <p:spPr>
           <a:xfrm>
-            <a:off x="9072880" y="4416552"/>
-            <a:ext cx="200253" cy="205740"/>
+            <a:off x="9199880" y="4162552"/>
+            <a:ext cx="199390" cy="205740"/>
           </a:xfrm>
           <a:prstGeom prst="rect">
             <a:avLst/>
@@ -25290,14 +25172,14 @@
       </p:sp>
       <p:sp>
         <p:nvSpPr>
-          <p:cNvPr id="40" name="TextBox 39"/>
+          <p:cNvPr id="37" name="TextBox 36"/>
           <p:cNvSpPr txBox="1"/>
           <p:nvPr/>
         </p:nvSpPr>
         <p:spPr>
           <a:xfrm>
-            <a:off x="9771380" y="4416552"/>
-            <a:ext cx="185165" cy="205740"/>
+            <a:off x="9898380" y="4162552"/>
+            <a:ext cx="186690" cy="205740"/>
           </a:xfrm>
           <a:prstGeom prst="rect">
             <a:avLst/>
@@ -25326,14 +25208,14 @@
       </p:sp>
       <p:cxnSp>
         <p:nvCxnSpPr>
-          <p:cNvPr id="41" name="Connector 40"/>
+          <p:cNvPr id="38" name="Connector 37"/>
           <p:cNvCxnSpPr/>
           <p:nvPr/>
         </p:nvCxnSpPr>
         <p:spPr>
           <a:xfrm>
-            <a:off x="6311900" y="4673600"/>
-            <a:ext cx="4165600" cy="0"/>
+            <a:off x="6311900" y="4419600"/>
+            <a:ext cx="4292600" cy="0"/>
           </a:xfrm>
           <a:prstGeom prst="line">
             <a:avLst/>
@@ -25361,14 +25243,14 @@
       </p:cxnSp>
       <p:sp>
         <p:nvSpPr>
-          <p:cNvPr id="42" name="TextBox 41"/>
+          <p:cNvPr id="39" name="TextBox 38"/>
           <p:cNvSpPr txBox="1"/>
           <p:nvPr/>
         </p:nvSpPr>
         <p:spPr>
           <a:xfrm>
-            <a:off x="6341110" y="4708144"/>
-            <a:ext cx="205359" cy="240030"/>
+            <a:off x="6341110" y="4454144"/>
+            <a:ext cx="208279" cy="240030"/>
           </a:xfrm>
           <a:prstGeom prst="rect">
             <a:avLst/>
@@ -25397,14 +25279,14 @@
       </p:sp>
       <p:sp>
         <p:nvSpPr>
-          <p:cNvPr id="43" name="TextBox 42"/>
+          <p:cNvPr id="40" name="TextBox 39"/>
           <p:cNvSpPr txBox="1"/>
           <p:nvPr/>
         </p:nvSpPr>
         <p:spPr>
           <a:xfrm>
-            <a:off x="6976109" y="4708144"/>
-            <a:ext cx="214782" cy="240030"/>
+            <a:off x="7103109" y="4454144"/>
+            <a:ext cx="214629" cy="240030"/>
           </a:xfrm>
           <a:prstGeom prst="rect">
             <a:avLst/>
@@ -25433,14 +25315,14 @@
       </p:sp>
       <p:sp>
         <p:nvSpPr>
-          <p:cNvPr id="44" name="TextBox 43"/>
+          <p:cNvPr id="41" name="TextBox 40"/>
           <p:cNvSpPr txBox="1"/>
           <p:nvPr/>
         </p:nvSpPr>
         <p:spPr>
           <a:xfrm>
-            <a:off x="7674609" y="4708144"/>
-            <a:ext cx="223494" cy="240030"/>
+            <a:off x="7801609" y="4454144"/>
+            <a:ext cx="220979" cy="240030"/>
           </a:xfrm>
           <a:prstGeom prst="rect">
             <a:avLst/>
@@ -25469,14 +25351,14 @@
       </p:sp>
       <p:sp>
         <p:nvSpPr>
-          <p:cNvPr id="45" name="TextBox 44"/>
+          <p:cNvPr id="42" name="TextBox 41"/>
           <p:cNvSpPr txBox="1"/>
           <p:nvPr/>
         </p:nvSpPr>
         <p:spPr>
           <a:xfrm>
-            <a:off x="8373109" y="4708144"/>
-            <a:ext cx="220116" cy="240030"/>
+            <a:off x="8500110" y="4454144"/>
+            <a:ext cx="220979" cy="240030"/>
           </a:xfrm>
           <a:prstGeom prst="rect">
             <a:avLst/>
@@ -25505,14 +25387,14 @@
       </p:sp>
       <p:sp>
         <p:nvSpPr>
-          <p:cNvPr id="46" name="TextBox 45"/>
+          <p:cNvPr id="43" name="TextBox 42"/>
           <p:cNvSpPr txBox="1"/>
           <p:nvPr/>
         </p:nvSpPr>
         <p:spPr>
           <a:xfrm>
-            <a:off x="9071610" y="4708144"/>
-            <a:ext cx="229006" cy="240030"/>
+            <a:off x="9198610" y="4454144"/>
+            <a:ext cx="227329" cy="240030"/>
           </a:xfrm>
           <a:prstGeom prst="rect">
             <a:avLst/>
@@ -25541,14 +25423,14 @@
       </p:sp>
       <p:sp>
         <p:nvSpPr>
-          <p:cNvPr id="47" name="TextBox 46"/>
+          <p:cNvPr id="44" name="TextBox 43"/>
           <p:cNvSpPr txBox="1"/>
           <p:nvPr/>
         </p:nvSpPr>
         <p:spPr>
           <a:xfrm>
-            <a:off x="9770110" y="4708144"/>
-            <a:ext cx="211404" cy="240030"/>
+            <a:off x="9897110" y="4454144"/>
+            <a:ext cx="208279" cy="240030"/>
           </a:xfrm>
           <a:prstGeom prst="rect">
             <a:avLst/>
@@ -25577,14 +25459,60 @@
       </p:sp>
       <p:sp>
         <p:nvSpPr>
-          <p:cNvPr id="48" name="TextBox 47"/>
+          <p:cNvPr id="45" name="Rounded Rectangle 44"/>
+          <p:cNvSpPr/>
+          <p:nvPr/>
+        </p:nvSpPr>
+        <p:spPr>
+          <a:xfrm>
+            <a:off x="6261100" y="4724400"/>
+            <a:ext cx="4432300" cy="292100"/>
+          </a:xfrm>
+          <a:prstGeom prst="roundRect">
+            <a:avLst>
+              <a:gd name="adj" fmla="val 17391"/>
+            </a:avLst>
+          </a:prstGeom>
+          <a:solidFill>
+            <a:srgbClr val="DB7B72">
+              <a:alpha val="22000"/>
+            </a:srgbClr>
+          </a:solidFill>
+          <a:ln>
+            <a:noFill/>
+          </a:ln>
+          <a:effectLst/>
+        </p:spPr>
+        <p:style>
+          <a:lnRef idx="1">
+            <a:schemeClr val="accent1"/>
+          </a:lnRef>
+          <a:fillRef idx="3">
+            <a:schemeClr val="accent1"/>
+          </a:fillRef>
+          <a:effectRef idx="2">
+            <a:schemeClr val="accent1"/>
+          </a:effectRef>
+          <a:fontRef idx="minor">
+            <a:schemeClr val="lt1"/>
+          </a:fontRef>
+        </p:style>
+        <p:txBody>
+          <a:bodyPr rtlCol="0" anchor="ctr"/>
+          <a:lstStyle/>
+          <a:p/>
+        </p:txBody>
+      </p:sp>
+      <p:sp>
+        <p:nvSpPr>
+          <p:cNvPr id="46" name="TextBox 45"/>
           <p:cNvSpPr txBox="1"/>
           <p:nvPr/>
         </p:nvSpPr>
         <p:spPr>
           <a:xfrm>
-            <a:off x="6341110" y="5025644"/>
-            <a:ext cx="205359" cy="240030"/>
+            <a:off x="6341110" y="4771644"/>
+            <a:ext cx="208279" cy="240030"/>
           </a:xfrm>
           <a:prstGeom prst="rect">
             <a:avLst/>
@@ -25613,14 +25541,14 @@
       </p:sp>
       <p:sp>
         <p:nvSpPr>
-          <p:cNvPr id="49" name="TextBox 48"/>
+          <p:cNvPr id="47" name="TextBox 46"/>
           <p:cNvSpPr txBox="1"/>
           <p:nvPr/>
         </p:nvSpPr>
         <p:spPr>
           <a:xfrm>
-            <a:off x="6976109" y="5025644"/>
-            <a:ext cx="223494" cy="240030"/>
+            <a:off x="7103109" y="4771644"/>
+            <a:ext cx="220979" cy="240030"/>
           </a:xfrm>
           <a:prstGeom prst="rect">
             <a:avLst/>
@@ -25649,14 +25577,14 @@
       </p:sp>
       <p:sp>
         <p:nvSpPr>
-          <p:cNvPr id="50" name="TextBox 49"/>
+          <p:cNvPr id="48" name="TextBox 47"/>
           <p:cNvSpPr txBox="1"/>
           <p:nvPr/>
         </p:nvSpPr>
         <p:spPr>
           <a:xfrm>
-            <a:off x="7674609" y="5025644"/>
-            <a:ext cx="214782" cy="240030"/>
+            <a:off x="7801609" y="4771644"/>
+            <a:ext cx="214629" cy="240030"/>
           </a:xfrm>
           <a:prstGeom prst="rect">
             <a:avLst/>
@@ -25685,14 +25613,14 @@
       </p:sp>
       <p:sp>
         <p:nvSpPr>
-          <p:cNvPr id="51" name="TextBox 50"/>
+          <p:cNvPr id="49" name="TextBox 48"/>
           <p:cNvSpPr txBox="1"/>
           <p:nvPr/>
         </p:nvSpPr>
         <p:spPr>
           <a:xfrm>
-            <a:off x="8373109" y="5025644"/>
-            <a:ext cx="223494" cy="240030"/>
+            <a:off x="8500110" y="4771644"/>
+            <a:ext cx="220979" cy="240030"/>
           </a:xfrm>
           <a:prstGeom prst="rect">
             <a:avLst/>
@@ -25721,14 +25649,14 @@
       </p:sp>
       <p:sp>
         <p:nvSpPr>
-          <p:cNvPr id="52" name="TextBox 51"/>
+          <p:cNvPr id="50" name="TextBox 49"/>
           <p:cNvSpPr txBox="1"/>
           <p:nvPr/>
         </p:nvSpPr>
         <p:spPr>
           <a:xfrm>
-            <a:off x="9071610" y="5025644"/>
-            <a:ext cx="211404" cy="240030"/>
+            <a:off x="9198610" y="4771644"/>
+            <a:ext cx="208279" cy="240030"/>
           </a:xfrm>
           <a:prstGeom prst="rect">
             <a:avLst/>
@@ -25757,14 +25685,14 @@
       </p:sp>
       <p:sp>
         <p:nvSpPr>
-          <p:cNvPr id="53" name="TextBox 52"/>
+          <p:cNvPr id="51" name="TextBox 50"/>
           <p:cNvSpPr txBox="1"/>
           <p:nvPr/>
         </p:nvSpPr>
         <p:spPr>
           <a:xfrm>
-            <a:off x="9770110" y="5025644"/>
-            <a:ext cx="229006" cy="240030"/>
+            <a:off x="9897110" y="4771644"/>
+            <a:ext cx="227329" cy="240030"/>
           </a:xfrm>
           <a:prstGeom prst="rect">
             <a:avLst/>
@@ -25793,14 +25721,14 @@
       </p:sp>
       <p:sp>
         <p:nvSpPr>
-          <p:cNvPr id="54" name="TextBox 53"/>
+          <p:cNvPr id="52" name="TextBox 51"/>
           <p:cNvSpPr txBox="1"/>
           <p:nvPr/>
         </p:nvSpPr>
         <p:spPr>
           <a:xfrm>
-            <a:off x="6341110" y="5343144"/>
-            <a:ext cx="205359" cy="240030"/>
+            <a:off x="6341110" y="5089144"/>
+            <a:ext cx="208279" cy="240030"/>
           </a:xfrm>
           <a:prstGeom prst="rect">
             <a:avLst/>
@@ -25829,14 +25757,14 @@
       </p:sp>
       <p:sp>
         <p:nvSpPr>
-          <p:cNvPr id="55" name="TextBox 54"/>
+          <p:cNvPr id="53" name="TextBox 52"/>
           <p:cNvSpPr txBox="1"/>
           <p:nvPr/>
         </p:nvSpPr>
         <p:spPr>
           <a:xfrm>
-            <a:off x="6976109" y="5343144"/>
-            <a:ext cx="214782" cy="240030"/>
+            <a:off x="7103109" y="5089144"/>
+            <a:ext cx="214629" cy="240030"/>
           </a:xfrm>
           <a:prstGeom prst="rect">
             <a:avLst/>
@@ -25865,14 +25793,14 @@
       </p:sp>
       <p:sp>
         <p:nvSpPr>
-          <p:cNvPr id="56" name="TextBox 55"/>
+          <p:cNvPr id="54" name="TextBox 53"/>
           <p:cNvSpPr txBox="1"/>
           <p:nvPr/>
         </p:nvSpPr>
         <p:spPr>
           <a:xfrm>
-            <a:off x="7674609" y="5343144"/>
-            <a:ext cx="223494" cy="240030"/>
+            <a:off x="7801609" y="5089144"/>
+            <a:ext cx="220979" cy="240030"/>
           </a:xfrm>
           <a:prstGeom prst="rect">
             <a:avLst/>
@@ -25901,14 +25829,14 @@
       </p:sp>
       <p:sp>
         <p:nvSpPr>
-          <p:cNvPr id="57" name="TextBox 56"/>
+          <p:cNvPr id="55" name="TextBox 54"/>
           <p:cNvSpPr txBox="1"/>
           <p:nvPr/>
         </p:nvSpPr>
         <p:spPr>
           <a:xfrm>
-            <a:off x="8373109" y="5343144"/>
-            <a:ext cx="214782" cy="240030"/>
+            <a:off x="8500110" y="5089144"/>
+            <a:ext cx="214629" cy="240030"/>
           </a:xfrm>
           <a:prstGeom prst="rect">
             <a:avLst/>
@@ -25937,14 +25865,14 @@
       </p:sp>
       <p:sp>
         <p:nvSpPr>
-          <p:cNvPr id="58" name="TextBox 57"/>
+          <p:cNvPr id="56" name="TextBox 55"/>
           <p:cNvSpPr txBox="1"/>
           <p:nvPr/>
         </p:nvSpPr>
         <p:spPr>
           <a:xfrm>
-            <a:off x="9071610" y="5343144"/>
-            <a:ext cx="229006" cy="240030"/>
+            <a:off x="9198610" y="5089144"/>
+            <a:ext cx="227329" cy="240030"/>
           </a:xfrm>
           <a:prstGeom prst="rect">
             <a:avLst/>
@@ -25973,14 +25901,14 @@
       </p:sp>
       <p:sp>
         <p:nvSpPr>
-          <p:cNvPr id="59" name="TextBox 58"/>
+          <p:cNvPr id="57" name="TextBox 56"/>
           <p:cNvSpPr txBox="1"/>
           <p:nvPr/>
         </p:nvSpPr>
         <p:spPr>
           <a:xfrm>
-            <a:off x="9770110" y="5343144"/>
-            <a:ext cx="211404" cy="240030"/>
+            <a:off x="9897110" y="5089144"/>
+            <a:ext cx="208279" cy="240030"/>
           </a:xfrm>
           <a:prstGeom prst="rect">
             <a:avLst/>
@@ -26009,14 +25937,60 @@
       </p:sp>
       <p:sp>
         <p:nvSpPr>
-          <p:cNvPr id="60" name="TextBox 59"/>
+          <p:cNvPr id="58" name="Rounded Rectangle 57"/>
+          <p:cNvSpPr/>
+          <p:nvPr/>
+        </p:nvSpPr>
+        <p:spPr>
+          <a:xfrm>
+            <a:off x="6261100" y="5359400"/>
+            <a:ext cx="4432300" cy="292100"/>
+          </a:xfrm>
+          <a:prstGeom prst="roundRect">
+            <a:avLst>
+              <a:gd name="adj" fmla="val 17391"/>
+            </a:avLst>
+          </a:prstGeom>
+          <a:solidFill>
+            <a:srgbClr val="DB7B72">
+              <a:alpha val="22000"/>
+            </a:srgbClr>
+          </a:solidFill>
+          <a:ln>
+            <a:noFill/>
+          </a:ln>
+          <a:effectLst/>
+        </p:spPr>
+        <p:style>
+          <a:lnRef idx="1">
+            <a:schemeClr val="accent1"/>
+          </a:lnRef>
+          <a:fillRef idx="3">
+            <a:schemeClr val="accent1"/>
+          </a:fillRef>
+          <a:effectRef idx="2">
+            <a:schemeClr val="accent1"/>
+          </a:effectRef>
+          <a:fontRef idx="minor">
+            <a:schemeClr val="lt1"/>
+          </a:fontRef>
+        </p:style>
+        <p:txBody>
+          <a:bodyPr rtlCol="0" anchor="ctr"/>
+          <a:lstStyle/>
+          <a:p/>
+        </p:txBody>
+      </p:sp>
+      <p:sp>
+        <p:nvSpPr>
+          <p:cNvPr id="59" name="TextBox 58"/>
           <p:cNvSpPr txBox="1"/>
           <p:nvPr/>
         </p:nvSpPr>
         <p:spPr>
           <a:xfrm>
-            <a:off x="6341110" y="5660644"/>
-            <a:ext cx="205359" cy="240030"/>
+            <a:off x="6341110" y="5406644"/>
+            <a:ext cx="208279" cy="240030"/>
           </a:xfrm>
           <a:prstGeom prst="rect">
             <a:avLst/>
@@ -26045,14 +26019,14 @@
       </p:sp>
       <p:sp>
         <p:nvSpPr>
-          <p:cNvPr id="61" name="TextBox 60"/>
+          <p:cNvPr id="60" name="TextBox 59"/>
           <p:cNvSpPr txBox="1"/>
           <p:nvPr/>
         </p:nvSpPr>
         <p:spPr>
           <a:xfrm>
-            <a:off x="6976109" y="5660644"/>
-            <a:ext cx="223494" cy="240030"/>
+            <a:off x="7103109" y="5406644"/>
+            <a:ext cx="220979" cy="240030"/>
           </a:xfrm>
           <a:prstGeom prst="rect">
             <a:avLst/>
@@ -26081,14 +26055,14 @@
       </p:sp>
       <p:sp>
         <p:nvSpPr>
-          <p:cNvPr id="62" name="TextBox 61"/>
+          <p:cNvPr id="61" name="TextBox 60"/>
           <p:cNvSpPr txBox="1"/>
           <p:nvPr/>
         </p:nvSpPr>
         <p:spPr>
           <a:xfrm>
-            <a:off x="7674609" y="5660644"/>
-            <a:ext cx="214782" cy="240030"/>
+            <a:off x="7801609" y="5406644"/>
+            <a:ext cx="214629" cy="240030"/>
           </a:xfrm>
           <a:prstGeom prst="rect">
             <a:avLst/>
@@ -26117,14 +26091,14 @@
       </p:sp>
       <p:sp>
         <p:nvSpPr>
-          <p:cNvPr id="63" name="TextBox 62"/>
+          <p:cNvPr id="62" name="TextBox 61"/>
           <p:cNvSpPr txBox="1"/>
           <p:nvPr/>
         </p:nvSpPr>
         <p:spPr>
           <a:xfrm>
-            <a:off x="8373109" y="5660644"/>
-            <a:ext cx="223494" cy="240030"/>
+            <a:off x="8500110" y="5406644"/>
+            <a:ext cx="220979" cy="240030"/>
           </a:xfrm>
           <a:prstGeom prst="rect">
             <a:avLst/>
@@ -26153,14 +26127,14 @@
       </p:sp>
       <p:sp>
         <p:nvSpPr>
-          <p:cNvPr id="64" name="TextBox 63"/>
+          <p:cNvPr id="63" name="TextBox 62"/>
           <p:cNvSpPr txBox="1"/>
           <p:nvPr/>
         </p:nvSpPr>
         <p:spPr>
           <a:xfrm>
-            <a:off x="9071610" y="5660644"/>
-            <a:ext cx="211404" cy="240030"/>
+            <a:off x="9198610" y="5406644"/>
+            <a:ext cx="208279" cy="240030"/>
           </a:xfrm>
           <a:prstGeom prst="rect">
             <a:avLst/>
@@ -26189,14 +26163,14 @@
       </p:sp>
       <p:sp>
         <p:nvSpPr>
-          <p:cNvPr id="65" name="TextBox 64"/>
+          <p:cNvPr id="64" name="TextBox 63"/>
           <p:cNvSpPr txBox="1"/>
           <p:nvPr/>
         </p:nvSpPr>
         <p:spPr>
           <a:xfrm>
-            <a:off x="9770110" y="5660644"/>
-            <a:ext cx="229006" cy="240030"/>
+            <a:off x="9897110" y="5406644"/>
+            <a:ext cx="227329" cy="240030"/>
           </a:xfrm>
           <a:prstGeom prst="rect">
             <a:avLst/>
@@ -26449,7 +26423,7 @@
         <p:spPr>
           <a:xfrm>
             <a:off x="563880" y="6512052"/>
-            <a:ext cx="1655826" cy="205740"/>
+            <a:ext cx="1647189" cy="205740"/>
           </a:xfrm>
           <a:prstGeom prst="rect">
             <a:avLst/>
@@ -26484,8 +26458,8 @@
         </p:nvSpPr>
         <p:spPr>
           <a:xfrm>
-            <a:off x="11108524" y="6499098"/>
-            <a:ext cx="561505" cy="222885"/>
+            <a:off x="11113770" y="6499098"/>
+            <a:ext cx="556260" cy="222885"/>
           </a:xfrm>
           <a:prstGeom prst="rect">
             <a:avLst/>
@@ -26520,8 +26494,8 @@
         </p:nvSpPr>
         <p:spPr>
           <a:xfrm>
-            <a:off x="9601809" y="377952"/>
-            <a:ext cx="2064410" cy="205740"/>
+            <a:off x="9307830" y="377952"/>
+            <a:ext cx="2358390" cy="205740"/>
           </a:xfrm>
           <a:prstGeom prst="rect">
             <a:avLst/>
@@ -26543,7 +26517,7 @@
                 <a:latin typeface="Noto Sans SC"/>
                 <a:ea typeface="Noto Sans SC"/>
               </a:rPr>
-              <a:t>影片 《圈子从哪里来》 02:08</a:t>
+              <a:t>影片 《精讲：规则与停止》 02:03</a:t>
             </a:r>
           </a:p>
         </p:txBody>
@@ -26963,8 +26937,8 @@
         </p:nvSpPr>
         <p:spPr>
           <a:xfrm>
-            <a:off x="7720817" y="1492474"/>
-            <a:ext cx="241808" cy="274320"/>
+            <a:off x="7720436" y="1492474"/>
+            <a:ext cx="242570" cy="274320"/>
           </a:xfrm>
           <a:prstGeom prst="rect">
             <a:avLst/>
@@ -27079,8 +27053,8 @@
         </p:nvSpPr>
         <p:spPr>
           <a:xfrm>
-            <a:off x="7432413" y="2459763"/>
-            <a:ext cx="241808" cy="274320"/>
+            <a:off x="7432032" y="2459763"/>
+            <a:ext cx="242570" cy="274320"/>
           </a:xfrm>
           <a:prstGeom prst="rect">
             <a:avLst/>
@@ -27195,8 +27169,8 @@
         </p:nvSpPr>
         <p:spPr>
           <a:xfrm>
-            <a:off x="8533733" y="2544380"/>
-            <a:ext cx="241808" cy="274320"/>
+            <a:off x="8533352" y="2544380"/>
+            <a:ext cx="242570" cy="274320"/>
           </a:xfrm>
           <a:prstGeom prst="rect">
             <a:avLst/>
@@ -27310,8 +27284,8 @@
         </p:nvSpPr>
         <p:spPr>
           <a:xfrm>
-            <a:off x="9088416" y="3769165"/>
-            <a:ext cx="361695" cy="274320"/>
+            <a:off x="9087654" y="3769165"/>
+            <a:ext cx="363220" cy="274320"/>
           </a:xfrm>
           <a:prstGeom prst="rect">
             <a:avLst/>
@@ -27425,8 +27399,8 @@
         </p:nvSpPr>
         <p:spPr>
           <a:xfrm>
-            <a:off x="8004937" y="4249176"/>
-            <a:ext cx="241808" cy="274320"/>
+            <a:off x="8004556" y="4249176"/>
+            <a:ext cx="242570" cy="274320"/>
           </a:xfrm>
           <a:prstGeom prst="rect">
             <a:avLst/>
@@ -27540,8 +27514,8 @@
         </p:nvSpPr>
         <p:spPr>
           <a:xfrm>
-            <a:off x="8999286" y="4890996"/>
-            <a:ext cx="241808" cy="274320"/>
+            <a:off x="8998905" y="4890996"/>
+            <a:ext cx="242570" cy="274320"/>
           </a:xfrm>
           <a:prstGeom prst="rect">
             <a:avLst/>
@@ -27620,8 +27594,8 @@
         </p:nvSpPr>
         <p:spPr>
           <a:xfrm>
-            <a:off x="6635075" y="1783076"/>
-            <a:ext cx="269659" cy="291465"/>
+            <a:off x="6635284" y="1783076"/>
+            <a:ext cx="269240" cy="291465"/>
           </a:xfrm>
           <a:prstGeom prst="rect">
             <a:avLst/>
@@ -27700,8 +27674,8 @@
         </p:nvSpPr>
         <p:spPr>
           <a:xfrm>
-            <a:off x="8795987" y="1635506"/>
-            <a:ext cx="276567" cy="291465"/>
+            <a:off x="8796476" y="1635506"/>
+            <a:ext cx="275590" cy="291465"/>
           </a:xfrm>
           <a:prstGeom prst="rect">
             <a:avLst/>
@@ -27780,8 +27754,8 @@
         </p:nvSpPr>
         <p:spPr>
           <a:xfrm>
-            <a:off x="7962453" y="3455541"/>
-            <a:ext cx="271170" cy="291465"/>
+            <a:off x="7963418" y="3455541"/>
+            <a:ext cx="269240" cy="291465"/>
           </a:xfrm>
           <a:prstGeom prst="rect">
             <a:avLst/>
@@ -27860,8 +27834,8 @@
         </p:nvSpPr>
         <p:spPr>
           <a:xfrm>
-            <a:off x="10169748" y="4488534"/>
-            <a:ext cx="283692" cy="291465"/>
+            <a:off x="10170625" y="4488534"/>
+            <a:ext cx="281939" cy="291465"/>
           </a:xfrm>
           <a:prstGeom prst="rect">
             <a:avLst/>
@@ -27940,8 +27914,8 @@
         </p:nvSpPr>
         <p:spPr>
           <a:xfrm>
-            <a:off x="7720928" y="5128006"/>
-            <a:ext cx="262318" cy="291465"/>
+            <a:off x="7720643" y="5128006"/>
+            <a:ext cx="262890" cy="291465"/>
           </a:xfrm>
           <a:prstGeom prst="rect">
             <a:avLst/>
@@ -27976,8 +27950,8 @@
         </p:nvSpPr>
         <p:spPr>
           <a:xfrm>
-            <a:off x="7436707" y="5689600"/>
-            <a:ext cx="2271585" cy="292100"/>
+            <a:off x="7432675" y="5689600"/>
+            <a:ext cx="2279650" cy="292100"/>
           </a:xfrm>
           <a:prstGeom prst="roundRect">
             <a:avLst>
@@ -28022,8 +27996,8 @@
         </p:nvSpPr>
         <p:spPr>
           <a:xfrm>
-            <a:off x="7482427" y="5749798"/>
-            <a:ext cx="2180145" cy="222885"/>
+            <a:off x="7478395" y="5749798"/>
+            <a:ext cx="2188210" cy="222885"/>
           </a:xfrm>
           <a:prstGeom prst="rect">
             <a:avLst/>
@@ -28276,7 +28250,7 @@
         <p:spPr>
           <a:xfrm>
             <a:off x="563880" y="6512052"/>
-            <a:ext cx="1655826" cy="205740"/>
+            <a:ext cx="1647189" cy="205740"/>
           </a:xfrm>
           <a:prstGeom prst="rect">
             <a:avLst/>
@@ -28311,8 +28285,8 @@
         </p:nvSpPr>
         <p:spPr>
           <a:xfrm>
-            <a:off x="11108524" y="6499098"/>
-            <a:ext cx="561505" cy="222885"/>
+            <a:off x="11113770" y="6499098"/>
+            <a:ext cx="556260" cy="222885"/>
           </a:xfrm>
           <a:prstGeom prst="rect">
             <a:avLst/>
@@ -28347,8 +28321,8 @@
         </p:nvSpPr>
         <p:spPr>
           <a:xfrm>
-            <a:off x="9601809" y="377952"/>
-            <a:ext cx="2064410" cy="205740"/>
+            <a:off x="9612630" y="377952"/>
+            <a:ext cx="2053589" cy="205740"/>
           </a:xfrm>
           <a:prstGeom prst="rect">
             <a:avLst/>
@@ -28370,7 +28344,7 @@
                 <a:latin typeface="Noto Sans SC"/>
                 <a:ea typeface="Noto Sans SC"/>
               </a:rPr>
-              <a:t>影片 《圈子从哪里来》 02:23</a:t>
+              <a:t>影片 《圈子从哪里来》 05:09</a:t>
             </a:r>
           </a:p>
         </p:txBody>
@@ -30792,7 +30766,7 @@
             <a:avLst/>
           </a:prstGeom>
           <a:solidFill>
-            <a:srgbClr val="E8A06A"/>
+            <a:srgbClr val="77CDBB"/>
           </a:solidFill>
           <a:ln w="12700">
             <a:solidFill>
@@ -30836,7 +30810,7 @@
             <a:avLst/>
           </a:prstGeom>
           <a:solidFill>
-            <a:srgbClr val="E8A06A"/>
+            <a:srgbClr val="77CDBB"/>
           </a:solidFill>
           <a:ln w="12700">
             <a:solidFill>
@@ -30880,7 +30854,7 @@
             <a:avLst/>
           </a:prstGeom>
           <a:solidFill>
-            <a:srgbClr val="E8A06A"/>
+            <a:srgbClr val="77CDBB"/>
           </a:solidFill>
           <a:ln w="12700">
             <a:solidFill>
@@ -30924,7 +30898,7 @@
             <a:avLst/>
           </a:prstGeom>
           <a:solidFill>
-            <a:srgbClr val="E8A06A"/>
+            <a:srgbClr val="77CDBB"/>
           </a:solidFill>
           <a:ln w="12700">
             <a:solidFill>
@@ -30968,7 +30942,7 @@
             <a:avLst/>
           </a:prstGeom>
           <a:solidFill>
-            <a:srgbClr val="E8A06A"/>
+            <a:srgbClr val="77CDBB"/>
           </a:solidFill>
           <a:ln w="12700">
             <a:solidFill>
@@ -31012,7 +30986,7 @@
             <a:avLst/>
           </a:prstGeom>
           <a:solidFill>
-            <a:srgbClr val="E8A06A"/>
+            <a:srgbClr val="77CDBB"/>
           </a:solidFill>
           <a:ln w="12700">
             <a:solidFill>
@@ -31056,7 +31030,7 @@
             <a:avLst/>
           </a:prstGeom>
           <a:solidFill>
-            <a:srgbClr val="E8A06A"/>
+            <a:srgbClr val="77CDBB"/>
           </a:solidFill>
           <a:ln w="12700">
             <a:solidFill>
@@ -31100,7 +31074,7 @@
             <a:avLst/>
           </a:prstGeom>
           <a:solidFill>
-            <a:srgbClr val="E8A06A"/>
+            <a:srgbClr val="77CDBB"/>
           </a:solidFill>
           <a:ln w="12700">
             <a:solidFill>
@@ -31496,7 +31470,7 @@
             <a:avLst/>
           </a:prstGeom>
           <a:solidFill>
-            <a:srgbClr val="E8A06A"/>
+            <a:srgbClr val="D8BB78"/>
           </a:solidFill>
           <a:ln w="12700">
             <a:solidFill>
@@ -31540,7 +31514,7 @@
             <a:avLst/>
           </a:prstGeom>
           <a:solidFill>
-            <a:srgbClr val="E8A06A"/>
+            <a:srgbClr val="D8BB78"/>
           </a:solidFill>
           <a:ln w="12700">
             <a:solidFill>
@@ -31584,7 +31558,7 @@
             <a:avLst/>
           </a:prstGeom>
           <a:solidFill>
-            <a:srgbClr val="E8A06A"/>
+            <a:srgbClr val="D8BB78"/>
           </a:solidFill>
           <a:ln w="12700">
             <a:solidFill>
@@ -31628,7 +31602,7 @@
             <a:avLst/>
           </a:prstGeom>
           <a:solidFill>
-            <a:srgbClr val="E8A06A"/>
+            <a:srgbClr val="D8BB78"/>
           </a:solidFill>
           <a:ln w="12700">
             <a:solidFill>
@@ -31672,7 +31646,7 @@
             <a:avLst/>
           </a:prstGeom>
           <a:solidFill>
-            <a:srgbClr val="E8A06A"/>
+            <a:srgbClr val="D8BB78"/>
           </a:solidFill>
           <a:ln w="12700">
             <a:solidFill>
@@ -31716,7 +31690,7 @@
             <a:avLst/>
           </a:prstGeom>
           <a:solidFill>
-            <a:srgbClr val="E8A06A"/>
+            <a:srgbClr val="D8BB78"/>
           </a:solidFill>
           <a:ln w="12700">
             <a:solidFill>
@@ -31760,7 +31734,7 @@
             <a:avLst/>
           </a:prstGeom>
           <a:solidFill>
-            <a:srgbClr val="E8A06A"/>
+            <a:srgbClr val="D8BB78"/>
           </a:solidFill>
           <a:ln w="12700">
             <a:solidFill>
@@ -31804,7 +31778,7 @@
             <a:avLst/>
           </a:prstGeom>
           <a:solidFill>
-            <a:srgbClr val="E8A06A"/>
+            <a:srgbClr val="D8BB78"/>
           </a:solidFill>
           <a:ln w="12700">
             <a:solidFill>
@@ -31841,8 +31815,8 @@
         </p:nvSpPr>
         <p:spPr>
           <a:xfrm>
-            <a:off x="7760982" y="5689600"/>
-            <a:ext cx="1750034" cy="292100"/>
+            <a:off x="7759700" y="5689600"/>
+            <a:ext cx="1752600" cy="292100"/>
           </a:xfrm>
           <a:prstGeom prst="roundRect">
             <a:avLst>
@@ -31887,8 +31861,8 @@
         </p:nvSpPr>
         <p:spPr>
           <a:xfrm>
-            <a:off x="7806702" y="5749798"/>
-            <a:ext cx="1658594" cy="222885"/>
+            <a:off x="7805420" y="5749798"/>
+            <a:ext cx="1661160" cy="222885"/>
           </a:xfrm>
           <a:prstGeom prst="rect">
             <a:avLst/>

</xml_diff>